<commit_message>
Modified the side bar
</commit_message>
<xml_diff>
--- a/figs/DIYfigures_ipe2.pptx
+++ b/figs/DIYfigures_ipe2.pptx
@@ -7,6 +7,7 @@
   <p:sldIdLst>
     <p:sldId id="256" r:id="rId2"/>
     <p:sldId id="257" r:id="rId3"/>
+    <p:sldId id="258" r:id="rId4"/>
   </p:sldIdLst>
   <p:sldSz cx="12192000" cy="6858000"/>
   <p:notesSz cx="6858000" cy="9144000"/>
@@ -113,6 +114,3323 @@
 </p:presentation>
 </file>
 
+<file path=ppt/diagrams/colors1.xml><?xml version="1.0" encoding="utf-8"?>
+<dgm:colorsDef xmlns:dgm="http://schemas.openxmlformats.org/drawingml/2006/diagram" xmlns:a="http://schemas.openxmlformats.org/drawingml/2006/main" uniqueId="urn:microsoft.com/office/officeart/2005/8/colors/accent0_1">
+  <dgm:title val=""/>
+  <dgm:desc val=""/>
+  <dgm:catLst>
+    <dgm:cat type="mainScheme" pri="10100"/>
+  </dgm:catLst>
+  <dgm:styleLbl name="node0">
+    <dgm:fillClrLst meth="repeat">
+      <a:schemeClr val="lt1"/>
+    </dgm:fillClrLst>
+    <dgm:linClrLst meth="repeat">
+      <a:schemeClr val="dk1">
+        <a:shade val="80000"/>
+      </a:schemeClr>
+    </dgm:linClrLst>
+    <dgm:effectClrLst/>
+    <dgm:txLinClrLst/>
+    <dgm:txFillClrLst meth="repeat">
+      <a:schemeClr val="dk1"/>
+    </dgm:txFillClrLst>
+    <dgm:txEffectClrLst/>
+  </dgm:styleLbl>
+  <dgm:styleLbl name="node0NoLn">
+    <dgm:fillClrLst meth="repeat">
+      <a:schemeClr val="lt1"/>
+    </dgm:fillClrLst>
+    <dgm:linClrLst meth="repeat">
+      <a:schemeClr val="dk1">
+        <a:shade val="80000"/>
+      </a:schemeClr>
+    </dgm:linClrLst>
+    <dgm:effectClrLst/>
+    <dgm:txLinClrLst/>
+    <dgm:txFillClrLst meth="repeat">
+      <a:schemeClr val="dk1"/>
+    </dgm:txFillClrLst>
+    <dgm:txEffectClrLst/>
+  </dgm:styleLbl>
+  <dgm:styleLbl name="node1">
+    <dgm:fillClrLst meth="repeat">
+      <a:schemeClr val="lt1"/>
+    </dgm:fillClrLst>
+    <dgm:linClrLst meth="repeat">
+      <a:schemeClr val="dk1">
+        <a:shade val="80000"/>
+      </a:schemeClr>
+    </dgm:linClrLst>
+    <dgm:effectClrLst/>
+    <dgm:txLinClrLst/>
+    <dgm:txFillClrLst meth="repeat">
+      <a:schemeClr val="dk1"/>
+    </dgm:txFillClrLst>
+    <dgm:txEffectClrLst/>
+  </dgm:styleLbl>
+  <dgm:styleLbl name="node1NoLn">
+    <dgm:fillClrLst meth="repeat">
+      <a:schemeClr val="lt1"/>
+    </dgm:fillClrLst>
+    <dgm:linClrLst meth="repeat">
+      <a:schemeClr val="dk1">
+        <a:shade val="80000"/>
+      </a:schemeClr>
+    </dgm:linClrLst>
+    <dgm:effectClrLst/>
+    <dgm:txLinClrLst/>
+    <dgm:txFillClrLst meth="repeat">
+      <a:schemeClr val="dk1"/>
+    </dgm:txFillClrLst>
+    <dgm:txEffectClrLst/>
+  </dgm:styleLbl>
+  <dgm:styleLbl name="ltNode1NoLn">
+    <dgm:fillClrLst meth="repeat">
+      <a:schemeClr val="lt1">
+        <a:tint val="75000"/>
+      </a:schemeClr>
+    </dgm:fillClrLst>
+    <dgm:linClrLst meth="repeat">
+      <a:schemeClr val="dk1">
+        <a:shade val="80000"/>
+      </a:schemeClr>
+    </dgm:linClrLst>
+    <dgm:effectClrLst/>
+    <dgm:txLinClrLst/>
+    <dgm:txFillClrLst meth="repeat">
+      <a:schemeClr val="dk1"/>
+    </dgm:txFillClrLst>
+    <dgm:txEffectClrLst/>
+  </dgm:styleLbl>
+  <dgm:styleLbl name="alignNode1">
+    <dgm:fillClrLst meth="repeat">
+      <a:schemeClr val="lt1"/>
+    </dgm:fillClrLst>
+    <dgm:linClrLst meth="repeat">
+      <a:schemeClr val="dk1">
+        <a:shade val="80000"/>
+      </a:schemeClr>
+    </dgm:linClrLst>
+    <dgm:effectClrLst/>
+    <dgm:txLinClrLst/>
+    <dgm:txFillClrLst meth="repeat">
+      <a:schemeClr val="dk1"/>
+    </dgm:txFillClrLst>
+    <dgm:txEffectClrLst/>
+  </dgm:styleLbl>
+  <dgm:styleLbl name="lnNode1">
+    <dgm:fillClrLst meth="repeat">
+      <a:schemeClr val="lt1"/>
+    </dgm:fillClrLst>
+    <dgm:linClrLst meth="repeat">
+      <a:schemeClr val="dk1">
+        <a:shade val="80000"/>
+      </a:schemeClr>
+    </dgm:linClrLst>
+    <dgm:effectClrLst/>
+    <dgm:txLinClrLst/>
+    <dgm:txFillClrLst meth="repeat">
+      <a:schemeClr val="dk1"/>
+    </dgm:txFillClrLst>
+    <dgm:txEffectClrLst/>
+  </dgm:styleLbl>
+  <dgm:styleLbl name="vennNode1">
+    <dgm:fillClrLst meth="repeat">
+      <a:schemeClr val="lt1">
+        <a:alpha val="50000"/>
+      </a:schemeClr>
+    </dgm:fillClrLst>
+    <dgm:linClrLst meth="repeat">
+      <a:schemeClr val="dk1">
+        <a:shade val="80000"/>
+      </a:schemeClr>
+    </dgm:linClrLst>
+    <dgm:effectClrLst/>
+    <dgm:txLinClrLst/>
+    <dgm:txFillClrLst/>
+    <dgm:txEffectClrLst/>
+  </dgm:styleLbl>
+  <dgm:styleLbl name="node2">
+    <dgm:fillClrLst meth="repeat">
+      <a:schemeClr val="lt1"/>
+    </dgm:fillClrLst>
+    <dgm:linClrLst meth="repeat">
+      <a:schemeClr val="dk1">
+        <a:shade val="80000"/>
+      </a:schemeClr>
+    </dgm:linClrLst>
+    <dgm:effectClrLst/>
+    <dgm:txLinClrLst/>
+    <dgm:txFillClrLst meth="repeat">
+      <a:schemeClr val="dk1"/>
+    </dgm:txFillClrLst>
+    <dgm:txEffectClrLst/>
+  </dgm:styleLbl>
+  <dgm:styleLbl name="node2NoLn">
+    <dgm:fillClrLst meth="repeat">
+      <a:schemeClr val="lt1"/>
+    </dgm:fillClrLst>
+    <dgm:linClrLst meth="repeat">
+      <a:schemeClr val="dk1">
+        <a:shade val="80000"/>
+      </a:schemeClr>
+    </dgm:linClrLst>
+    <dgm:effectClrLst/>
+    <dgm:txLinClrLst/>
+    <dgm:txFillClrLst meth="repeat">
+      <a:schemeClr val="dk1"/>
+    </dgm:txFillClrLst>
+    <dgm:txEffectClrLst/>
+  </dgm:styleLbl>
+  <dgm:styleLbl name="node3">
+    <dgm:fillClrLst meth="repeat">
+      <a:schemeClr val="lt1"/>
+    </dgm:fillClrLst>
+    <dgm:linClrLst meth="repeat">
+      <a:schemeClr val="dk1">
+        <a:shade val="80000"/>
+      </a:schemeClr>
+    </dgm:linClrLst>
+    <dgm:effectClrLst/>
+    <dgm:txLinClrLst/>
+    <dgm:txFillClrLst meth="repeat">
+      <a:schemeClr val="dk1"/>
+    </dgm:txFillClrLst>
+    <dgm:txEffectClrLst/>
+  </dgm:styleLbl>
+  <dgm:styleLbl name="node3NoLn">
+    <dgm:fillClrLst meth="repeat">
+      <a:schemeClr val="lt1"/>
+    </dgm:fillClrLst>
+    <dgm:linClrLst meth="repeat">
+      <a:schemeClr val="dk1">
+        <a:shade val="80000"/>
+      </a:schemeClr>
+    </dgm:linClrLst>
+    <dgm:effectClrLst/>
+    <dgm:txLinClrLst/>
+    <dgm:txFillClrLst meth="repeat">
+      <a:schemeClr val="dk1"/>
+    </dgm:txFillClrLst>
+    <dgm:txEffectClrLst/>
+  </dgm:styleLbl>
+  <dgm:styleLbl name="node4">
+    <dgm:fillClrLst meth="repeat">
+      <a:schemeClr val="lt1"/>
+    </dgm:fillClrLst>
+    <dgm:linClrLst meth="repeat">
+      <a:schemeClr val="dk1">
+        <a:shade val="80000"/>
+      </a:schemeClr>
+    </dgm:linClrLst>
+    <dgm:effectClrLst/>
+    <dgm:txLinClrLst/>
+    <dgm:txFillClrLst meth="repeat">
+      <a:schemeClr val="dk1"/>
+    </dgm:txFillClrLst>
+    <dgm:txEffectClrLst/>
+  </dgm:styleLbl>
+  <dgm:styleLbl name="node4NoLn">
+    <dgm:fillClrLst meth="repeat">
+      <a:schemeClr val="lt1"/>
+    </dgm:fillClrLst>
+    <dgm:linClrLst meth="repeat">
+      <a:schemeClr val="dk1">
+        <a:shade val="80000"/>
+      </a:schemeClr>
+    </dgm:linClrLst>
+    <dgm:effectClrLst/>
+    <dgm:txLinClrLst/>
+    <dgm:txFillClrLst meth="repeat">
+      <a:schemeClr val="dk1"/>
+    </dgm:txFillClrLst>
+    <dgm:txEffectClrLst/>
+  </dgm:styleLbl>
+  <dgm:styleLbl name="fgImgPlace1">
+    <dgm:fillClrLst meth="repeat">
+      <a:schemeClr val="dk1">
+        <a:tint val="40000"/>
+      </a:schemeClr>
+    </dgm:fillClrLst>
+    <dgm:linClrLst meth="repeat">
+      <a:schemeClr val="dk1">
+        <a:shade val="80000"/>
+      </a:schemeClr>
+    </dgm:linClrLst>
+    <dgm:effectClrLst/>
+    <dgm:txLinClrLst/>
+    <dgm:txFillClrLst meth="repeat">
+      <a:schemeClr val="lt1"/>
+    </dgm:txFillClrLst>
+    <dgm:txEffectClrLst/>
+  </dgm:styleLbl>
+  <dgm:styleLbl name="alignImgPlace1">
+    <dgm:fillClrLst meth="repeat">
+      <a:schemeClr val="dk1">
+        <a:tint val="40000"/>
+      </a:schemeClr>
+    </dgm:fillClrLst>
+    <dgm:linClrLst meth="repeat">
+      <a:schemeClr val="dk1">
+        <a:shade val="80000"/>
+      </a:schemeClr>
+    </dgm:linClrLst>
+    <dgm:effectClrLst/>
+    <dgm:txLinClrLst/>
+    <dgm:txFillClrLst meth="repeat">
+      <a:schemeClr val="lt1"/>
+    </dgm:txFillClrLst>
+    <dgm:txEffectClrLst/>
+  </dgm:styleLbl>
+  <dgm:styleLbl name="bgImgPlace1">
+    <dgm:fillClrLst meth="repeat">
+      <a:schemeClr val="dk1">
+        <a:tint val="40000"/>
+      </a:schemeClr>
+    </dgm:fillClrLst>
+    <dgm:linClrLst meth="repeat">
+      <a:schemeClr val="dk1">
+        <a:shade val="80000"/>
+      </a:schemeClr>
+    </dgm:linClrLst>
+    <dgm:effectClrLst/>
+    <dgm:txLinClrLst/>
+    <dgm:txFillClrLst meth="repeat">
+      <a:schemeClr val="lt1"/>
+    </dgm:txFillClrLst>
+    <dgm:txEffectClrLst/>
+  </dgm:styleLbl>
+  <dgm:styleLbl name="sibTrans2D1">
+    <dgm:fillClrLst meth="repeat">
+      <a:schemeClr val="dk1">
+        <a:tint val="60000"/>
+      </a:schemeClr>
+    </dgm:fillClrLst>
+    <dgm:linClrLst meth="repeat">
+      <a:schemeClr val="dk1">
+        <a:tint val="60000"/>
+      </a:schemeClr>
+    </dgm:linClrLst>
+    <dgm:effectClrLst/>
+    <dgm:txLinClrLst/>
+    <dgm:txFillClrLst meth="repeat">
+      <a:schemeClr val="dk1"/>
+    </dgm:txFillClrLst>
+    <dgm:txEffectClrLst/>
+  </dgm:styleLbl>
+  <dgm:styleLbl name="fgSibTrans2D1">
+    <dgm:fillClrLst meth="repeat">
+      <a:schemeClr val="dk1">
+        <a:tint val="60000"/>
+      </a:schemeClr>
+    </dgm:fillClrLst>
+    <dgm:linClrLst meth="repeat">
+      <a:schemeClr val="dk1">
+        <a:tint val="60000"/>
+      </a:schemeClr>
+    </dgm:linClrLst>
+    <dgm:effectClrLst/>
+    <dgm:txLinClrLst/>
+    <dgm:txFillClrLst meth="repeat">
+      <a:schemeClr val="dk1"/>
+    </dgm:txFillClrLst>
+    <dgm:txEffectClrLst/>
+  </dgm:styleLbl>
+  <dgm:styleLbl name="bgSibTrans2D1">
+    <dgm:fillClrLst meth="repeat">
+      <a:schemeClr val="dk1">
+        <a:tint val="60000"/>
+      </a:schemeClr>
+    </dgm:fillClrLst>
+    <dgm:linClrLst meth="repeat">
+      <a:schemeClr val="dk1">
+        <a:tint val="60000"/>
+      </a:schemeClr>
+    </dgm:linClrLst>
+    <dgm:effectClrLst/>
+    <dgm:txLinClrLst/>
+    <dgm:txFillClrLst meth="repeat">
+      <a:schemeClr val="dk1"/>
+    </dgm:txFillClrLst>
+    <dgm:txEffectClrLst/>
+  </dgm:styleLbl>
+  <dgm:styleLbl name="sibTrans1D1">
+    <dgm:fillClrLst meth="repeat">
+      <a:schemeClr val="dk1"/>
+    </dgm:fillClrLst>
+    <dgm:linClrLst meth="repeat">
+      <a:schemeClr val="dk1"/>
+    </dgm:linClrLst>
+    <dgm:effectClrLst/>
+    <dgm:txLinClrLst/>
+    <dgm:txFillClrLst meth="repeat">
+      <a:schemeClr val="tx1"/>
+    </dgm:txFillClrLst>
+    <dgm:txEffectClrLst/>
+  </dgm:styleLbl>
+  <dgm:styleLbl name="callout">
+    <dgm:fillClrLst meth="repeat">
+      <a:schemeClr val="dk1"/>
+    </dgm:fillClrLst>
+    <dgm:linClrLst meth="repeat">
+      <a:schemeClr val="dk1"/>
+    </dgm:linClrLst>
+    <dgm:effectClrLst/>
+    <dgm:txLinClrLst/>
+    <dgm:txFillClrLst meth="repeat">
+      <a:schemeClr val="tx1"/>
+    </dgm:txFillClrLst>
+    <dgm:txEffectClrLst/>
+  </dgm:styleLbl>
+  <dgm:styleLbl name="asst0">
+    <dgm:fillClrLst meth="repeat">
+      <a:schemeClr val="lt1"/>
+    </dgm:fillClrLst>
+    <dgm:linClrLst meth="repeat">
+      <a:schemeClr val="dk1">
+        <a:shade val="80000"/>
+      </a:schemeClr>
+    </dgm:linClrLst>
+    <dgm:effectClrLst/>
+    <dgm:txLinClrLst/>
+    <dgm:txFillClrLst meth="repeat">
+      <a:schemeClr val="dk1"/>
+    </dgm:txFillClrLst>
+    <dgm:txEffectClrLst/>
+  </dgm:styleLbl>
+  <dgm:styleLbl name="asst1">
+    <dgm:fillClrLst meth="repeat">
+      <a:schemeClr val="lt1"/>
+    </dgm:fillClrLst>
+    <dgm:linClrLst meth="repeat">
+      <a:schemeClr val="dk1">
+        <a:shade val="80000"/>
+      </a:schemeClr>
+    </dgm:linClrLst>
+    <dgm:effectClrLst/>
+    <dgm:txLinClrLst/>
+    <dgm:txFillClrLst meth="repeat">
+      <a:schemeClr val="dk1"/>
+    </dgm:txFillClrLst>
+    <dgm:txEffectClrLst/>
+  </dgm:styleLbl>
+  <dgm:styleLbl name="asst2">
+    <dgm:fillClrLst meth="repeat">
+      <a:schemeClr val="lt1"/>
+    </dgm:fillClrLst>
+    <dgm:linClrLst meth="repeat">
+      <a:schemeClr val="dk1">
+        <a:shade val="80000"/>
+      </a:schemeClr>
+    </dgm:linClrLst>
+    <dgm:effectClrLst/>
+    <dgm:txLinClrLst/>
+    <dgm:txFillClrLst meth="repeat">
+      <a:schemeClr val="dk1"/>
+    </dgm:txFillClrLst>
+    <dgm:txEffectClrLst/>
+  </dgm:styleLbl>
+  <dgm:styleLbl name="asst3">
+    <dgm:fillClrLst meth="repeat">
+      <a:schemeClr val="lt1"/>
+    </dgm:fillClrLst>
+    <dgm:linClrLst meth="repeat">
+      <a:schemeClr val="dk1">
+        <a:shade val="80000"/>
+      </a:schemeClr>
+    </dgm:linClrLst>
+    <dgm:effectClrLst/>
+    <dgm:txLinClrLst/>
+    <dgm:txFillClrLst meth="repeat">
+      <a:schemeClr val="dk1"/>
+    </dgm:txFillClrLst>
+    <dgm:txEffectClrLst/>
+  </dgm:styleLbl>
+  <dgm:styleLbl name="asst4">
+    <dgm:fillClrLst meth="repeat">
+      <a:schemeClr val="lt1"/>
+    </dgm:fillClrLst>
+    <dgm:linClrLst meth="repeat">
+      <a:schemeClr val="dk1">
+        <a:shade val="80000"/>
+      </a:schemeClr>
+    </dgm:linClrLst>
+    <dgm:effectClrLst/>
+    <dgm:txLinClrLst/>
+    <dgm:txFillClrLst meth="repeat">
+      <a:schemeClr val="dk1"/>
+    </dgm:txFillClrLst>
+    <dgm:txEffectClrLst/>
+  </dgm:styleLbl>
+  <dgm:styleLbl name="parChTrans2D1">
+    <dgm:fillClrLst meth="repeat">
+      <a:schemeClr val="dk1">
+        <a:tint val="60000"/>
+      </a:schemeClr>
+    </dgm:fillClrLst>
+    <dgm:linClrLst meth="repeat">
+      <a:schemeClr val="dk1">
+        <a:tint val="60000"/>
+      </a:schemeClr>
+    </dgm:linClrLst>
+    <dgm:effectClrLst/>
+    <dgm:txLinClrLst/>
+    <dgm:txFillClrLst/>
+    <dgm:txEffectClrLst/>
+  </dgm:styleLbl>
+  <dgm:styleLbl name="parChTrans2D2">
+    <dgm:fillClrLst meth="repeat">
+      <a:schemeClr val="dk1"/>
+    </dgm:fillClrLst>
+    <dgm:linClrLst meth="repeat">
+      <a:schemeClr val="dk1"/>
+    </dgm:linClrLst>
+    <dgm:effectClrLst/>
+    <dgm:txLinClrLst/>
+    <dgm:txFillClrLst/>
+    <dgm:txEffectClrLst/>
+  </dgm:styleLbl>
+  <dgm:styleLbl name="parChTrans2D3">
+    <dgm:fillClrLst meth="repeat">
+      <a:schemeClr val="dk1"/>
+    </dgm:fillClrLst>
+    <dgm:linClrLst meth="repeat">
+      <a:schemeClr val="dk1"/>
+    </dgm:linClrLst>
+    <dgm:effectClrLst/>
+    <dgm:txLinClrLst/>
+    <dgm:txFillClrLst/>
+    <dgm:txEffectClrLst/>
+  </dgm:styleLbl>
+  <dgm:styleLbl name="parChTrans2D4">
+    <dgm:fillClrLst meth="repeat">
+      <a:schemeClr val="dk1"/>
+    </dgm:fillClrLst>
+    <dgm:linClrLst meth="repeat">
+      <a:schemeClr val="dk1"/>
+    </dgm:linClrLst>
+    <dgm:effectClrLst/>
+    <dgm:txLinClrLst/>
+    <dgm:txFillClrLst meth="repeat">
+      <a:schemeClr val="lt1"/>
+    </dgm:txFillClrLst>
+    <dgm:txEffectClrLst/>
+  </dgm:styleLbl>
+  <dgm:styleLbl name="parChTrans1D1">
+    <dgm:fillClrLst meth="repeat">
+      <a:schemeClr val="dk1"/>
+    </dgm:fillClrLst>
+    <dgm:linClrLst meth="repeat">
+      <a:schemeClr val="dk1">
+        <a:shade val="60000"/>
+      </a:schemeClr>
+    </dgm:linClrLst>
+    <dgm:effectClrLst/>
+    <dgm:txLinClrLst/>
+    <dgm:txFillClrLst meth="repeat">
+      <a:schemeClr val="tx1"/>
+    </dgm:txFillClrLst>
+    <dgm:txEffectClrLst/>
+  </dgm:styleLbl>
+  <dgm:styleLbl name="parChTrans1D2">
+    <dgm:fillClrLst meth="repeat">
+      <a:schemeClr val="dk1"/>
+    </dgm:fillClrLst>
+    <dgm:linClrLst meth="repeat">
+      <a:schemeClr val="dk1">
+        <a:shade val="60000"/>
+      </a:schemeClr>
+    </dgm:linClrLst>
+    <dgm:effectClrLst/>
+    <dgm:txLinClrLst/>
+    <dgm:txFillClrLst meth="repeat">
+      <a:schemeClr val="tx1"/>
+    </dgm:txFillClrLst>
+    <dgm:txEffectClrLst/>
+  </dgm:styleLbl>
+  <dgm:styleLbl name="parChTrans1D3">
+    <dgm:fillClrLst meth="repeat">
+      <a:schemeClr val="dk1"/>
+    </dgm:fillClrLst>
+    <dgm:linClrLst meth="repeat">
+      <a:schemeClr val="dk1">
+        <a:shade val="80000"/>
+      </a:schemeClr>
+    </dgm:linClrLst>
+    <dgm:effectClrLst/>
+    <dgm:txLinClrLst/>
+    <dgm:txFillClrLst meth="repeat">
+      <a:schemeClr val="tx1"/>
+    </dgm:txFillClrLst>
+    <dgm:txEffectClrLst/>
+  </dgm:styleLbl>
+  <dgm:styleLbl name="parChTrans1D4">
+    <dgm:fillClrLst meth="repeat">
+      <a:schemeClr val="dk1"/>
+    </dgm:fillClrLst>
+    <dgm:linClrLst meth="repeat">
+      <a:schemeClr val="dk1">
+        <a:shade val="80000"/>
+      </a:schemeClr>
+    </dgm:linClrLst>
+    <dgm:effectClrLst/>
+    <dgm:txLinClrLst/>
+    <dgm:txFillClrLst meth="repeat">
+      <a:schemeClr val="tx1"/>
+    </dgm:txFillClrLst>
+    <dgm:txEffectClrLst/>
+  </dgm:styleLbl>
+  <dgm:styleLbl name="fgAcc1">
+    <dgm:fillClrLst meth="repeat">
+      <a:schemeClr val="dk1">
+        <a:alpha val="90000"/>
+        <a:tint val="40000"/>
+      </a:schemeClr>
+    </dgm:fillClrLst>
+    <dgm:linClrLst meth="repeat">
+      <a:schemeClr val="dk1"/>
+    </dgm:linClrLst>
+    <dgm:effectClrLst/>
+    <dgm:txLinClrLst/>
+    <dgm:txFillClrLst meth="repeat">
+      <a:schemeClr val="dk1"/>
+    </dgm:txFillClrLst>
+    <dgm:txEffectClrLst/>
+  </dgm:styleLbl>
+  <dgm:styleLbl name="conFgAcc1">
+    <dgm:fillClrLst meth="repeat">
+      <a:schemeClr val="dk1">
+        <a:alpha val="90000"/>
+        <a:tint val="40000"/>
+      </a:schemeClr>
+    </dgm:fillClrLst>
+    <dgm:linClrLst meth="repeat">
+      <a:schemeClr val="dk1"/>
+    </dgm:linClrLst>
+    <dgm:effectClrLst/>
+    <dgm:txLinClrLst/>
+    <dgm:txFillClrLst meth="repeat">
+      <a:schemeClr val="dk1"/>
+    </dgm:txFillClrLst>
+    <dgm:txEffectClrLst/>
+  </dgm:styleLbl>
+  <dgm:styleLbl name="alignAcc1">
+    <dgm:fillClrLst meth="repeat">
+      <a:schemeClr val="dk1">
+        <a:alpha val="90000"/>
+        <a:tint val="40000"/>
+      </a:schemeClr>
+    </dgm:fillClrLst>
+    <dgm:linClrLst meth="repeat">
+      <a:schemeClr val="dk1"/>
+    </dgm:linClrLst>
+    <dgm:effectClrLst/>
+    <dgm:txLinClrLst/>
+    <dgm:txFillClrLst meth="repeat">
+      <a:schemeClr val="dk1"/>
+    </dgm:txFillClrLst>
+    <dgm:txEffectClrLst/>
+  </dgm:styleLbl>
+  <dgm:styleLbl name="trAlignAcc1">
+    <dgm:fillClrLst meth="repeat">
+      <a:schemeClr val="dk1">
+        <a:alpha val="40000"/>
+        <a:tint val="40000"/>
+      </a:schemeClr>
+    </dgm:fillClrLst>
+    <dgm:linClrLst meth="repeat">
+      <a:schemeClr val="dk1"/>
+    </dgm:linClrLst>
+    <dgm:effectClrLst/>
+    <dgm:txLinClrLst/>
+    <dgm:txFillClrLst meth="repeat">
+      <a:schemeClr val="dk1"/>
+    </dgm:txFillClrLst>
+    <dgm:txEffectClrLst/>
+  </dgm:styleLbl>
+  <dgm:styleLbl name="bgAcc1">
+    <dgm:fillClrLst meth="repeat">
+      <a:schemeClr val="dk1">
+        <a:alpha val="90000"/>
+        <a:tint val="40000"/>
+      </a:schemeClr>
+    </dgm:fillClrLst>
+    <dgm:linClrLst meth="repeat">
+      <a:schemeClr val="dk1"/>
+    </dgm:linClrLst>
+    <dgm:effectClrLst/>
+    <dgm:txLinClrLst/>
+    <dgm:txFillClrLst meth="repeat">
+      <a:schemeClr val="dk1"/>
+    </dgm:txFillClrLst>
+    <dgm:txEffectClrLst/>
+  </dgm:styleLbl>
+  <dgm:styleLbl name="solidFgAcc1">
+    <dgm:fillClrLst meth="repeat">
+      <a:schemeClr val="lt1"/>
+    </dgm:fillClrLst>
+    <dgm:linClrLst meth="repeat">
+      <a:schemeClr val="dk1"/>
+    </dgm:linClrLst>
+    <dgm:effectClrLst/>
+    <dgm:txLinClrLst/>
+    <dgm:txFillClrLst meth="repeat">
+      <a:schemeClr val="dk1"/>
+    </dgm:txFillClrLst>
+    <dgm:txEffectClrLst/>
+  </dgm:styleLbl>
+  <dgm:styleLbl name="solidAlignAcc1">
+    <dgm:fillClrLst meth="repeat">
+      <a:schemeClr val="lt1"/>
+    </dgm:fillClrLst>
+    <dgm:linClrLst meth="repeat">
+      <a:schemeClr val="dk1"/>
+    </dgm:linClrLst>
+    <dgm:effectClrLst/>
+    <dgm:txLinClrLst/>
+    <dgm:txFillClrLst meth="repeat">
+      <a:schemeClr val="dk1"/>
+    </dgm:txFillClrLst>
+    <dgm:txEffectClrLst/>
+  </dgm:styleLbl>
+  <dgm:styleLbl name="solidBgAcc1">
+    <dgm:fillClrLst meth="repeat">
+      <a:schemeClr val="lt1"/>
+    </dgm:fillClrLst>
+    <dgm:linClrLst meth="repeat">
+      <a:schemeClr val="dk1"/>
+    </dgm:linClrLst>
+    <dgm:effectClrLst/>
+    <dgm:txLinClrLst/>
+    <dgm:txFillClrLst meth="repeat">
+      <a:schemeClr val="dk1"/>
+    </dgm:txFillClrLst>
+    <dgm:txEffectClrLst/>
+  </dgm:styleLbl>
+  <dgm:styleLbl name="fgAccFollowNode1">
+    <dgm:fillClrLst meth="repeat">
+      <a:schemeClr val="lt1">
+        <a:alpha val="90000"/>
+        <a:tint val="40000"/>
+      </a:schemeClr>
+    </dgm:fillClrLst>
+    <dgm:linClrLst meth="repeat">
+      <a:schemeClr val="dk1">
+        <a:alpha val="90000"/>
+      </a:schemeClr>
+    </dgm:linClrLst>
+    <dgm:effectClrLst/>
+    <dgm:txLinClrLst/>
+    <dgm:txFillClrLst meth="repeat">
+      <a:schemeClr val="dk1"/>
+    </dgm:txFillClrLst>
+    <dgm:txEffectClrLst/>
+  </dgm:styleLbl>
+  <dgm:styleLbl name="alignAccFollowNode1">
+    <dgm:fillClrLst meth="repeat">
+      <a:schemeClr val="lt1">
+        <a:alpha val="90000"/>
+        <a:tint val="40000"/>
+      </a:schemeClr>
+    </dgm:fillClrLst>
+    <dgm:linClrLst meth="repeat">
+      <a:schemeClr val="dk1">
+        <a:alpha val="90000"/>
+      </a:schemeClr>
+    </dgm:linClrLst>
+    <dgm:effectClrLst/>
+    <dgm:txLinClrLst/>
+    <dgm:txFillClrLst meth="repeat">
+      <a:schemeClr val="dk1"/>
+    </dgm:txFillClrLst>
+    <dgm:txEffectClrLst/>
+  </dgm:styleLbl>
+  <dgm:styleLbl name="bgAccFollowNode1">
+    <dgm:fillClrLst meth="repeat">
+      <a:schemeClr val="lt1">
+        <a:alpha val="90000"/>
+        <a:tint val="40000"/>
+      </a:schemeClr>
+    </dgm:fillClrLst>
+    <dgm:linClrLst meth="repeat">
+      <a:schemeClr val="dk1">
+        <a:alpha val="90000"/>
+      </a:schemeClr>
+    </dgm:linClrLst>
+    <dgm:effectClrLst/>
+    <dgm:txLinClrLst/>
+    <dgm:txFillClrLst meth="repeat">
+      <a:schemeClr val="dk1"/>
+    </dgm:txFillClrLst>
+    <dgm:txEffectClrLst/>
+  </dgm:styleLbl>
+  <dgm:styleLbl name="fgAcc0">
+    <dgm:fillClrLst meth="repeat">
+      <a:schemeClr val="dk1">
+        <a:alpha val="90000"/>
+        <a:tint val="40000"/>
+      </a:schemeClr>
+    </dgm:fillClrLst>
+    <dgm:linClrLst meth="repeat">
+      <a:schemeClr val="dk1"/>
+    </dgm:linClrLst>
+    <dgm:effectClrLst/>
+    <dgm:txLinClrLst/>
+    <dgm:txFillClrLst meth="repeat">
+      <a:schemeClr val="dk1"/>
+    </dgm:txFillClrLst>
+    <dgm:txEffectClrLst/>
+  </dgm:styleLbl>
+  <dgm:styleLbl name="fgAcc2">
+    <dgm:fillClrLst meth="repeat">
+      <a:schemeClr val="dk1">
+        <a:alpha val="90000"/>
+        <a:tint val="40000"/>
+      </a:schemeClr>
+    </dgm:fillClrLst>
+    <dgm:linClrLst meth="repeat">
+      <a:schemeClr val="dk1"/>
+    </dgm:linClrLst>
+    <dgm:effectClrLst/>
+    <dgm:txLinClrLst/>
+    <dgm:txFillClrLst meth="repeat">
+      <a:schemeClr val="dk1"/>
+    </dgm:txFillClrLst>
+    <dgm:txEffectClrLst/>
+  </dgm:styleLbl>
+  <dgm:styleLbl name="fgAcc3">
+    <dgm:fillClrLst meth="repeat">
+      <a:schemeClr val="dk1">
+        <a:alpha val="90000"/>
+        <a:tint val="40000"/>
+      </a:schemeClr>
+    </dgm:fillClrLst>
+    <dgm:linClrLst meth="repeat">
+      <a:schemeClr val="dk1"/>
+    </dgm:linClrLst>
+    <dgm:effectClrLst/>
+    <dgm:txLinClrLst/>
+    <dgm:txFillClrLst meth="repeat">
+      <a:schemeClr val="dk1"/>
+    </dgm:txFillClrLst>
+    <dgm:txEffectClrLst/>
+  </dgm:styleLbl>
+  <dgm:styleLbl name="fgAcc4">
+    <dgm:fillClrLst meth="repeat">
+      <a:schemeClr val="dk1">
+        <a:alpha val="90000"/>
+        <a:tint val="40000"/>
+      </a:schemeClr>
+    </dgm:fillClrLst>
+    <dgm:linClrLst meth="repeat">
+      <a:schemeClr val="dk1"/>
+    </dgm:linClrLst>
+    <dgm:effectClrLst/>
+    <dgm:txLinClrLst/>
+    <dgm:txFillClrLst meth="repeat">
+      <a:schemeClr val="dk1"/>
+    </dgm:txFillClrLst>
+    <dgm:txEffectClrLst/>
+  </dgm:styleLbl>
+  <dgm:styleLbl name="bgShp">
+    <dgm:fillClrLst meth="repeat">
+      <a:schemeClr val="dk1">
+        <a:tint val="40000"/>
+      </a:schemeClr>
+    </dgm:fillClrLst>
+    <dgm:linClrLst meth="repeat">
+      <a:schemeClr val="dk1"/>
+    </dgm:linClrLst>
+    <dgm:effectClrLst/>
+    <dgm:txLinClrLst/>
+    <dgm:txFillClrLst meth="repeat">
+      <a:schemeClr val="dk1"/>
+    </dgm:txFillClrLst>
+    <dgm:txEffectClrLst/>
+  </dgm:styleLbl>
+  <dgm:styleLbl name="dkBgShp">
+    <dgm:fillClrLst meth="repeat">
+      <a:schemeClr val="dk1">
+        <a:shade val="80000"/>
+      </a:schemeClr>
+    </dgm:fillClrLst>
+    <dgm:linClrLst meth="repeat">
+      <a:schemeClr val="dk1"/>
+    </dgm:linClrLst>
+    <dgm:effectClrLst/>
+    <dgm:txLinClrLst/>
+    <dgm:txFillClrLst meth="repeat">
+      <a:schemeClr val="lt1"/>
+    </dgm:txFillClrLst>
+    <dgm:txEffectClrLst/>
+  </dgm:styleLbl>
+  <dgm:styleLbl name="trBgShp">
+    <dgm:fillClrLst meth="repeat">
+      <a:schemeClr val="dk1">
+        <a:tint val="50000"/>
+        <a:alpha val="40000"/>
+      </a:schemeClr>
+    </dgm:fillClrLst>
+    <dgm:linClrLst meth="repeat">
+      <a:schemeClr val="dk1"/>
+    </dgm:linClrLst>
+    <dgm:effectClrLst/>
+    <dgm:txLinClrLst/>
+    <dgm:txFillClrLst meth="repeat">
+      <a:schemeClr val="lt1"/>
+    </dgm:txFillClrLst>
+    <dgm:txEffectClrLst/>
+  </dgm:styleLbl>
+  <dgm:styleLbl name="fgShp">
+    <dgm:fillClrLst meth="repeat">
+      <a:schemeClr val="dk1">
+        <a:tint val="60000"/>
+      </a:schemeClr>
+    </dgm:fillClrLst>
+    <dgm:linClrLst meth="repeat">
+      <a:schemeClr val="lt1"/>
+    </dgm:linClrLst>
+    <dgm:effectClrLst/>
+    <dgm:txLinClrLst/>
+    <dgm:txFillClrLst meth="repeat">
+      <a:schemeClr val="dk1"/>
+    </dgm:txFillClrLst>
+    <dgm:txEffectClrLst/>
+  </dgm:styleLbl>
+  <dgm:styleLbl name="revTx">
+    <dgm:fillClrLst meth="repeat">
+      <a:schemeClr val="lt1">
+        <a:alpha val="0"/>
+      </a:schemeClr>
+    </dgm:fillClrLst>
+    <dgm:linClrLst meth="repeat">
+      <a:schemeClr val="dk1">
+        <a:alpha val="0"/>
+      </a:schemeClr>
+    </dgm:linClrLst>
+    <dgm:effectClrLst/>
+    <dgm:txLinClrLst/>
+    <dgm:txFillClrLst meth="repeat">
+      <a:schemeClr val="tx1"/>
+    </dgm:txFillClrLst>
+    <dgm:txEffectClrLst/>
+  </dgm:styleLbl>
+  <dgm:styleLbl name="revTxLt">
+    <dgm:fillClrLst meth="repeat">
+      <a:schemeClr val="lt1">
+        <a:alpha val="0"/>
+      </a:schemeClr>
+    </dgm:fillClrLst>
+    <dgm:linClrLst meth="repeat">
+      <a:schemeClr val="dk1">
+        <a:alpha val="0"/>
+      </a:schemeClr>
+    </dgm:linClrLst>
+    <dgm:effectClrLst/>
+    <dgm:txLinClrLst/>
+    <dgm:txFillClrLst meth="repeat">
+      <a:schemeClr val="dk1"/>
+    </dgm:txFillClrLst>
+    <dgm:txEffectClrLst/>
+  </dgm:styleLbl>
+</dgm:colorsDef>
+</file>
+
+<file path=ppt/diagrams/data1.xml><?xml version="1.0" encoding="utf-8"?>
+<dgm:dataModel xmlns:dgm="http://schemas.openxmlformats.org/drawingml/2006/diagram" xmlns:a="http://schemas.openxmlformats.org/drawingml/2006/main">
+  <dgm:ptLst>
+    <dgm:pt modelId="{E6215070-95AD-E046-B635-485C3AB1168F}" type="doc">
+      <dgm:prSet loTypeId="urn:microsoft.com/office/officeart/2005/8/layout/process4" loCatId="" qsTypeId="urn:microsoft.com/office/officeart/2005/8/quickstyle/simple1" qsCatId="simple" csTypeId="urn:microsoft.com/office/officeart/2005/8/colors/accent0_1" csCatId="mainScheme" phldr="1"/>
+      <dgm:spPr/>
+    </dgm:pt>
+    <dgm:pt modelId="{B446C157-7E71-A341-AE84-E3072807250C}">
+      <dgm:prSet phldrT="[テキスト]" custT="1"/>
+      <dgm:spPr/>
+      <dgm:t>
+        <a:bodyPr/>
+        <a:lstStyle/>
+        <a:p>
+          <a:r>
+            <a:rPr kumimoji="1" lang="ja-JP" altLang="en-US" sz="3200" b="1" i="0">
+              <a:latin typeface="Hiragino Sans W7" panose="020B0400000000000000" pitchFamily="34" charset="-128"/>
+              <a:ea typeface="Hiragino Sans W7" panose="020B0400000000000000" pitchFamily="34" charset="-128"/>
+            </a:rPr>
+            <a:t>財政支出の</a:t>
+          </a:r>
+          <a:r>
+            <a:rPr kumimoji="1" lang="ja-JP" altLang="en-US" sz="3200" b="1" i="0">
+              <a:latin typeface="Hiragino Sans W8" panose="020B0400000000000000" pitchFamily="34" charset="-128"/>
+              <a:ea typeface="Hiragino Sans W8" panose="020B0400000000000000" pitchFamily="34" charset="-128"/>
+            </a:rPr>
+            <a:t>拡大</a:t>
+          </a:r>
+        </a:p>
+      </dgm:t>
+    </dgm:pt>
+    <dgm:pt modelId="{5F216E02-05DA-794F-83A9-3B87A8FC1D61}" type="parTrans" cxnId="{21DA7000-69AB-FC4B-990D-DEED42B09D40}">
+      <dgm:prSet/>
+      <dgm:spPr/>
+      <dgm:t>
+        <a:bodyPr/>
+        <a:lstStyle/>
+        <a:p>
+          <a:endParaRPr kumimoji="1" lang="ja-JP" altLang="en-US"/>
+        </a:p>
+      </dgm:t>
+    </dgm:pt>
+    <dgm:pt modelId="{8A007857-5F71-3A41-8293-5ECE691A3105}" type="sibTrans" cxnId="{21DA7000-69AB-FC4B-990D-DEED42B09D40}">
+      <dgm:prSet phldrT="1" phldr="0"/>
+      <dgm:spPr/>
+    </dgm:pt>
+    <dgm:pt modelId="{F5B0360A-9C81-7A40-A3FF-88D789178DBA}">
+      <dgm:prSet phldrT="[テキスト]" custT="1"/>
+      <dgm:spPr/>
+      <dgm:t>
+        <a:bodyPr/>
+        <a:lstStyle/>
+        <a:p>
+          <a:r>
+            <a:rPr kumimoji="1" lang="ja-JP" altLang="en-US" sz="3200" b="1" i="0">
+              <a:latin typeface="Hiragino Sans W8" panose="020B0400000000000000" pitchFamily="34" charset="-128"/>
+              <a:ea typeface="Hiragino Sans W8" panose="020B0400000000000000" pitchFamily="34" charset="-128"/>
+            </a:rPr>
+            <a:t>インフレ</a:t>
+          </a:r>
+        </a:p>
+      </dgm:t>
+    </dgm:pt>
+    <dgm:pt modelId="{C1B0866D-8DFA-5D40-970F-ACC5EA503832}" type="parTrans" cxnId="{F6F10C65-1906-9F48-A6B7-762938A63195}">
+      <dgm:prSet/>
+      <dgm:spPr/>
+      <dgm:t>
+        <a:bodyPr/>
+        <a:lstStyle/>
+        <a:p>
+          <a:endParaRPr kumimoji="1" lang="ja-JP" altLang="en-US"/>
+        </a:p>
+      </dgm:t>
+    </dgm:pt>
+    <dgm:pt modelId="{C88BBB61-AB74-CD49-B294-24FC1E352E0D}" type="sibTrans" cxnId="{F6F10C65-1906-9F48-A6B7-762938A63195}">
+      <dgm:prSet phldrT="2" phldr="0"/>
+      <dgm:spPr/>
+    </dgm:pt>
+    <dgm:pt modelId="{A0D4E924-2981-6447-AD39-7FC63D9A7F9C}">
+      <dgm:prSet phldrT="[テキスト]" custT="1"/>
+      <dgm:spPr/>
+      <dgm:t>
+        <a:bodyPr/>
+        <a:lstStyle/>
+        <a:p>
+          <a:r>
+            <a:rPr kumimoji="1" lang="ja-JP" altLang="en-US" sz="3200" b="1" i="0">
+              <a:latin typeface="Hiragino Sans W8" panose="020B0400000000000000" pitchFamily="34" charset="-128"/>
+              <a:ea typeface="Hiragino Sans W8" panose="020B0400000000000000" pitchFamily="34" charset="-128"/>
+            </a:rPr>
+            <a:t>金融引き締め</a:t>
+          </a:r>
+        </a:p>
+      </dgm:t>
+    </dgm:pt>
+    <dgm:pt modelId="{69FF6B60-864F-2747-BE22-D6DABDA9C227}" type="parTrans" cxnId="{C0424B1A-D9D7-1445-ACA5-EA3B8F2B3734}">
+      <dgm:prSet/>
+      <dgm:spPr/>
+      <dgm:t>
+        <a:bodyPr/>
+        <a:lstStyle/>
+        <a:p>
+          <a:endParaRPr kumimoji="1" lang="ja-JP" altLang="en-US"/>
+        </a:p>
+      </dgm:t>
+    </dgm:pt>
+    <dgm:pt modelId="{12BB6BF3-FA6E-D24D-A35C-A6BBD8D701BE}" type="sibTrans" cxnId="{C0424B1A-D9D7-1445-ACA5-EA3B8F2B3734}">
+      <dgm:prSet phldrT="3" phldr="0"/>
+      <dgm:spPr/>
+    </dgm:pt>
+    <dgm:pt modelId="{B37D487D-8097-374A-8F74-B6ED6D941218}">
+      <dgm:prSet phldrT="[テキスト]" custT="1"/>
+      <dgm:spPr/>
+      <dgm:t>
+        <a:bodyPr/>
+        <a:lstStyle/>
+        <a:p>
+          <a:r>
+            <a:rPr kumimoji="1" lang="ja-JP" altLang="en-US" sz="3200" b="1" i="0">
+              <a:latin typeface="Hiragino Sans W8" panose="020B0400000000000000" pitchFamily="34" charset="-128"/>
+              <a:ea typeface="Hiragino Sans W8" panose="020B0400000000000000" pitchFamily="34" charset="-128"/>
+            </a:rPr>
+            <a:t>通貨増価</a:t>
+          </a:r>
+        </a:p>
+      </dgm:t>
+    </dgm:pt>
+    <dgm:pt modelId="{E1501BDB-5084-B745-991D-0564F634D875}" type="parTrans" cxnId="{7C7BF463-42E2-134B-9EB5-BB08943DCEAA}">
+      <dgm:prSet/>
+      <dgm:spPr/>
+      <dgm:t>
+        <a:bodyPr/>
+        <a:lstStyle/>
+        <a:p>
+          <a:endParaRPr kumimoji="1" lang="ja-JP" altLang="en-US"/>
+        </a:p>
+      </dgm:t>
+    </dgm:pt>
+    <dgm:pt modelId="{952DE767-E093-944C-89C3-96C3372E4A7E}" type="sibTrans" cxnId="{7C7BF463-42E2-134B-9EB5-BB08943DCEAA}">
+      <dgm:prSet phldrT="4" phldr="0"/>
+      <dgm:spPr/>
+    </dgm:pt>
+    <dgm:pt modelId="{608B8FC6-44E1-C94E-8336-88AF52159D33}">
+      <dgm:prSet phldrT="[テキスト]" custT="1"/>
+      <dgm:spPr/>
+      <dgm:t>
+        <a:bodyPr/>
+        <a:lstStyle/>
+        <a:p>
+          <a:r>
+            <a:rPr kumimoji="1" lang="ja-JP" altLang="en-US" sz="3200" b="1" i="0">
+              <a:latin typeface="Hiragino Sans W8" panose="020B0400000000000000" pitchFamily="34" charset="-128"/>
+              <a:ea typeface="Hiragino Sans W8" panose="020B0400000000000000" pitchFamily="34" charset="-128"/>
+            </a:rPr>
+            <a:t>輸出阻害</a:t>
+          </a:r>
+          <a:endParaRPr kumimoji="1" lang="ja-JP" altLang="en-US" sz="2000" b="1" i="0">
+            <a:latin typeface="Hiragino Sans W8" panose="020B0400000000000000" pitchFamily="34" charset="-128"/>
+            <a:ea typeface="Hiragino Sans W8" panose="020B0400000000000000" pitchFamily="34" charset="-128"/>
+          </a:endParaRPr>
+        </a:p>
+      </dgm:t>
+    </dgm:pt>
+    <dgm:pt modelId="{6C5F1CEB-93ED-7044-9C30-85CACAF61EA5}" type="parTrans" cxnId="{D7DFC02F-FA97-1847-A929-3695287FB650}">
+      <dgm:prSet/>
+      <dgm:spPr/>
+      <dgm:t>
+        <a:bodyPr/>
+        <a:lstStyle/>
+        <a:p>
+          <a:endParaRPr kumimoji="1" lang="ja-JP" altLang="en-US"/>
+        </a:p>
+      </dgm:t>
+    </dgm:pt>
+    <dgm:pt modelId="{A29ACE09-CC4E-5B49-8B21-8B55A6283F4C}" type="sibTrans" cxnId="{D7DFC02F-FA97-1847-A929-3695287FB650}">
+      <dgm:prSet phldrT="5" phldr="0"/>
+      <dgm:spPr/>
+    </dgm:pt>
+    <dgm:pt modelId="{FEDAD011-8EE1-FC45-A571-901D91F4CD73}">
+      <dgm:prSet phldrT="[テキスト]" custT="1"/>
+      <dgm:spPr/>
+      <dgm:t>
+        <a:bodyPr/>
+        <a:lstStyle/>
+        <a:p>
+          <a:r>
+            <a:rPr kumimoji="1" lang="ja-JP" altLang="en-US" sz="3200" b="1" i="0">
+              <a:latin typeface="Hiragino Sans W8" panose="020B0400000000000000" pitchFamily="34" charset="-128"/>
+              <a:ea typeface="Hiragino Sans W8" panose="020B0400000000000000" pitchFamily="34" charset="-128"/>
+            </a:rPr>
+            <a:t>経済成長阻害</a:t>
+          </a:r>
+        </a:p>
+      </dgm:t>
+    </dgm:pt>
+    <dgm:pt modelId="{53D2ECF0-1857-CC49-9E0C-7D9DAC4AA7C0}" type="parTrans" cxnId="{39418908-E92C-F749-87E6-8B5C45A80144}">
+      <dgm:prSet/>
+      <dgm:spPr/>
+      <dgm:t>
+        <a:bodyPr/>
+        <a:lstStyle/>
+        <a:p>
+          <a:endParaRPr kumimoji="1" lang="ja-JP" altLang="en-US"/>
+        </a:p>
+      </dgm:t>
+    </dgm:pt>
+    <dgm:pt modelId="{220F8D90-EE9C-8046-85F3-3B73D5484691}" type="sibTrans" cxnId="{39418908-E92C-F749-87E6-8B5C45A80144}">
+      <dgm:prSet/>
+      <dgm:spPr/>
+      <dgm:t>
+        <a:bodyPr/>
+        <a:lstStyle/>
+        <a:p>
+          <a:endParaRPr kumimoji="1" lang="ja-JP" altLang="en-US"/>
+        </a:p>
+      </dgm:t>
+    </dgm:pt>
+    <dgm:pt modelId="{9AF84F5C-9FBF-1347-A3F0-1AAB8D6B7E6E}" type="pres">
+      <dgm:prSet presAssocID="{E6215070-95AD-E046-B635-485C3AB1168F}" presName="Name0" presStyleCnt="0">
+        <dgm:presLayoutVars>
+          <dgm:dir/>
+          <dgm:animLvl val="lvl"/>
+          <dgm:resizeHandles val="exact"/>
+        </dgm:presLayoutVars>
+      </dgm:prSet>
+      <dgm:spPr/>
+    </dgm:pt>
+    <dgm:pt modelId="{012367D6-7DC4-9644-AB3B-B4386524A05E}" type="pres">
+      <dgm:prSet presAssocID="{FEDAD011-8EE1-FC45-A571-901D91F4CD73}" presName="boxAndChildren" presStyleCnt="0"/>
+      <dgm:spPr/>
+    </dgm:pt>
+    <dgm:pt modelId="{84A64D2F-A115-D844-BDA7-4425F5129A0C}" type="pres">
+      <dgm:prSet presAssocID="{FEDAD011-8EE1-FC45-A571-901D91F4CD73}" presName="parentTextBox" presStyleLbl="node1" presStyleIdx="0" presStyleCnt="6"/>
+      <dgm:spPr/>
+    </dgm:pt>
+    <dgm:pt modelId="{DC35C99E-30CE-244C-92B7-AE1CFCBD92AA}" type="pres">
+      <dgm:prSet presAssocID="{A29ACE09-CC4E-5B49-8B21-8B55A6283F4C}" presName="sp" presStyleCnt="0"/>
+      <dgm:spPr/>
+    </dgm:pt>
+    <dgm:pt modelId="{37ED7664-A217-EC44-8335-0637AF09792E}" type="pres">
+      <dgm:prSet presAssocID="{608B8FC6-44E1-C94E-8336-88AF52159D33}" presName="arrowAndChildren" presStyleCnt="0"/>
+      <dgm:spPr/>
+    </dgm:pt>
+    <dgm:pt modelId="{7C08FC82-A0B2-8546-9BEE-D11B023CC0E0}" type="pres">
+      <dgm:prSet presAssocID="{608B8FC6-44E1-C94E-8336-88AF52159D33}" presName="parentTextArrow" presStyleLbl="node1" presStyleIdx="1" presStyleCnt="6"/>
+      <dgm:spPr/>
+    </dgm:pt>
+    <dgm:pt modelId="{DB8B9CDC-C90B-B14A-B550-5A3BA182F7FF}" type="pres">
+      <dgm:prSet presAssocID="{952DE767-E093-944C-89C3-96C3372E4A7E}" presName="sp" presStyleCnt="0"/>
+      <dgm:spPr/>
+    </dgm:pt>
+    <dgm:pt modelId="{AF6D1F64-9B7F-F94A-87EB-95B86D5D400A}" type="pres">
+      <dgm:prSet presAssocID="{B37D487D-8097-374A-8F74-B6ED6D941218}" presName="arrowAndChildren" presStyleCnt="0"/>
+      <dgm:spPr/>
+    </dgm:pt>
+    <dgm:pt modelId="{ED576AFA-79E4-BA45-A4C2-D3808209888F}" type="pres">
+      <dgm:prSet presAssocID="{B37D487D-8097-374A-8F74-B6ED6D941218}" presName="parentTextArrow" presStyleLbl="node1" presStyleIdx="2" presStyleCnt="6"/>
+      <dgm:spPr/>
+    </dgm:pt>
+    <dgm:pt modelId="{6E90C472-88B4-4C4C-863B-0F37091D83E4}" type="pres">
+      <dgm:prSet presAssocID="{12BB6BF3-FA6E-D24D-A35C-A6BBD8D701BE}" presName="sp" presStyleCnt="0"/>
+      <dgm:spPr/>
+    </dgm:pt>
+    <dgm:pt modelId="{7CE98043-0CA9-814C-B187-C76FD1E6666E}" type="pres">
+      <dgm:prSet presAssocID="{A0D4E924-2981-6447-AD39-7FC63D9A7F9C}" presName="arrowAndChildren" presStyleCnt="0"/>
+      <dgm:spPr/>
+    </dgm:pt>
+    <dgm:pt modelId="{61A896E1-956C-764A-80FA-356EE9AC5E59}" type="pres">
+      <dgm:prSet presAssocID="{A0D4E924-2981-6447-AD39-7FC63D9A7F9C}" presName="parentTextArrow" presStyleLbl="node1" presStyleIdx="3" presStyleCnt="6"/>
+      <dgm:spPr/>
+    </dgm:pt>
+    <dgm:pt modelId="{C540290A-A5DE-6B44-B234-DF81AD15D0B6}" type="pres">
+      <dgm:prSet presAssocID="{C88BBB61-AB74-CD49-B294-24FC1E352E0D}" presName="sp" presStyleCnt="0"/>
+      <dgm:spPr/>
+    </dgm:pt>
+    <dgm:pt modelId="{128A6F93-9B6A-DC4F-AFE7-0B84010DC784}" type="pres">
+      <dgm:prSet presAssocID="{F5B0360A-9C81-7A40-A3FF-88D789178DBA}" presName="arrowAndChildren" presStyleCnt="0"/>
+      <dgm:spPr/>
+    </dgm:pt>
+    <dgm:pt modelId="{AAA1BBA0-2B9E-8244-A74D-6F23DD7EF9B1}" type="pres">
+      <dgm:prSet presAssocID="{F5B0360A-9C81-7A40-A3FF-88D789178DBA}" presName="parentTextArrow" presStyleLbl="node1" presStyleIdx="4" presStyleCnt="6"/>
+      <dgm:spPr/>
+    </dgm:pt>
+    <dgm:pt modelId="{262EB433-C931-2145-82CF-82609B0D405D}" type="pres">
+      <dgm:prSet presAssocID="{8A007857-5F71-3A41-8293-5ECE691A3105}" presName="sp" presStyleCnt="0"/>
+      <dgm:spPr/>
+    </dgm:pt>
+    <dgm:pt modelId="{8DEFD305-6867-8744-A984-1CB4A871BCC6}" type="pres">
+      <dgm:prSet presAssocID="{B446C157-7E71-A341-AE84-E3072807250C}" presName="arrowAndChildren" presStyleCnt="0"/>
+      <dgm:spPr/>
+    </dgm:pt>
+    <dgm:pt modelId="{6A9EE9A2-B242-924B-A517-EBFEDAE9CA00}" type="pres">
+      <dgm:prSet presAssocID="{B446C157-7E71-A341-AE84-E3072807250C}" presName="parentTextArrow" presStyleLbl="node1" presStyleIdx="5" presStyleCnt="6"/>
+      <dgm:spPr/>
+    </dgm:pt>
+  </dgm:ptLst>
+  <dgm:cxnLst>
+    <dgm:cxn modelId="{21DA7000-69AB-FC4B-990D-DEED42B09D40}" srcId="{E6215070-95AD-E046-B635-485C3AB1168F}" destId="{B446C157-7E71-A341-AE84-E3072807250C}" srcOrd="0" destOrd="0" parTransId="{5F216E02-05DA-794F-83A9-3B87A8FC1D61}" sibTransId="{8A007857-5F71-3A41-8293-5ECE691A3105}"/>
+    <dgm:cxn modelId="{39418908-E92C-F749-87E6-8B5C45A80144}" srcId="{E6215070-95AD-E046-B635-485C3AB1168F}" destId="{FEDAD011-8EE1-FC45-A571-901D91F4CD73}" srcOrd="5" destOrd="0" parTransId="{53D2ECF0-1857-CC49-9E0C-7D9DAC4AA7C0}" sibTransId="{220F8D90-EE9C-8046-85F3-3B73D5484691}"/>
+    <dgm:cxn modelId="{C0424B1A-D9D7-1445-ACA5-EA3B8F2B3734}" srcId="{E6215070-95AD-E046-B635-485C3AB1168F}" destId="{A0D4E924-2981-6447-AD39-7FC63D9A7F9C}" srcOrd="2" destOrd="0" parTransId="{69FF6B60-864F-2747-BE22-D6DABDA9C227}" sibTransId="{12BB6BF3-FA6E-D24D-A35C-A6BBD8D701BE}"/>
+    <dgm:cxn modelId="{D7DFC02F-FA97-1847-A929-3695287FB650}" srcId="{E6215070-95AD-E046-B635-485C3AB1168F}" destId="{608B8FC6-44E1-C94E-8336-88AF52159D33}" srcOrd="4" destOrd="0" parTransId="{6C5F1CEB-93ED-7044-9C30-85CACAF61EA5}" sibTransId="{A29ACE09-CC4E-5B49-8B21-8B55A6283F4C}"/>
+    <dgm:cxn modelId="{3678FB4C-E917-F74E-8505-DE24B20D5901}" type="presOf" srcId="{F5B0360A-9C81-7A40-A3FF-88D789178DBA}" destId="{AAA1BBA0-2B9E-8244-A74D-6F23DD7EF9B1}" srcOrd="0" destOrd="0" presId="urn:microsoft.com/office/officeart/2005/8/layout/process4"/>
+    <dgm:cxn modelId="{DE8A7D5F-B13F-8A49-9E42-D08A11D1C697}" type="presOf" srcId="{A0D4E924-2981-6447-AD39-7FC63D9A7F9C}" destId="{61A896E1-956C-764A-80FA-356EE9AC5E59}" srcOrd="0" destOrd="0" presId="urn:microsoft.com/office/officeart/2005/8/layout/process4"/>
+    <dgm:cxn modelId="{7C7BF463-42E2-134B-9EB5-BB08943DCEAA}" srcId="{E6215070-95AD-E046-B635-485C3AB1168F}" destId="{B37D487D-8097-374A-8F74-B6ED6D941218}" srcOrd="3" destOrd="0" parTransId="{E1501BDB-5084-B745-991D-0564F634D875}" sibTransId="{952DE767-E093-944C-89C3-96C3372E4A7E}"/>
+    <dgm:cxn modelId="{F6F10C65-1906-9F48-A6B7-762938A63195}" srcId="{E6215070-95AD-E046-B635-485C3AB1168F}" destId="{F5B0360A-9C81-7A40-A3FF-88D789178DBA}" srcOrd="1" destOrd="0" parTransId="{C1B0866D-8DFA-5D40-970F-ACC5EA503832}" sibTransId="{C88BBB61-AB74-CD49-B294-24FC1E352E0D}"/>
+    <dgm:cxn modelId="{0B402991-FE29-6441-B970-A7C6C6CBD0EA}" type="presOf" srcId="{E6215070-95AD-E046-B635-485C3AB1168F}" destId="{9AF84F5C-9FBF-1347-A3F0-1AAB8D6B7E6E}" srcOrd="0" destOrd="0" presId="urn:microsoft.com/office/officeart/2005/8/layout/process4"/>
+    <dgm:cxn modelId="{ED55E29F-337A-EB45-811B-29D853FDEE79}" type="presOf" srcId="{FEDAD011-8EE1-FC45-A571-901D91F4CD73}" destId="{84A64D2F-A115-D844-BDA7-4425F5129A0C}" srcOrd="0" destOrd="0" presId="urn:microsoft.com/office/officeart/2005/8/layout/process4"/>
+    <dgm:cxn modelId="{AD6496A6-C0CB-6442-B66F-80F665BEBBCB}" type="presOf" srcId="{B37D487D-8097-374A-8F74-B6ED6D941218}" destId="{ED576AFA-79E4-BA45-A4C2-D3808209888F}" srcOrd="0" destOrd="0" presId="urn:microsoft.com/office/officeart/2005/8/layout/process4"/>
+    <dgm:cxn modelId="{43F7E5A8-85D9-CC41-8E6B-544B96A6B128}" type="presOf" srcId="{608B8FC6-44E1-C94E-8336-88AF52159D33}" destId="{7C08FC82-A0B2-8546-9BEE-D11B023CC0E0}" srcOrd="0" destOrd="0" presId="urn:microsoft.com/office/officeart/2005/8/layout/process4"/>
+    <dgm:cxn modelId="{2F9426F7-503E-514E-919D-A3146DB44CCF}" type="presOf" srcId="{B446C157-7E71-A341-AE84-E3072807250C}" destId="{6A9EE9A2-B242-924B-A517-EBFEDAE9CA00}" srcOrd="0" destOrd="0" presId="urn:microsoft.com/office/officeart/2005/8/layout/process4"/>
+    <dgm:cxn modelId="{D8E6B6B6-6776-C848-9958-F4868BF96DF9}" type="presParOf" srcId="{9AF84F5C-9FBF-1347-A3F0-1AAB8D6B7E6E}" destId="{012367D6-7DC4-9644-AB3B-B4386524A05E}" srcOrd="0" destOrd="0" presId="urn:microsoft.com/office/officeart/2005/8/layout/process4"/>
+    <dgm:cxn modelId="{4973CF63-04BC-3E43-906E-E96EFCEC5523}" type="presParOf" srcId="{012367D6-7DC4-9644-AB3B-B4386524A05E}" destId="{84A64D2F-A115-D844-BDA7-4425F5129A0C}" srcOrd="0" destOrd="0" presId="urn:microsoft.com/office/officeart/2005/8/layout/process4"/>
+    <dgm:cxn modelId="{19A659EE-6D4A-D042-BC24-1B847DE8BB05}" type="presParOf" srcId="{9AF84F5C-9FBF-1347-A3F0-1AAB8D6B7E6E}" destId="{DC35C99E-30CE-244C-92B7-AE1CFCBD92AA}" srcOrd="1" destOrd="0" presId="urn:microsoft.com/office/officeart/2005/8/layout/process4"/>
+    <dgm:cxn modelId="{4BBB0410-0D2C-EE41-95B5-101E64698598}" type="presParOf" srcId="{9AF84F5C-9FBF-1347-A3F0-1AAB8D6B7E6E}" destId="{37ED7664-A217-EC44-8335-0637AF09792E}" srcOrd="2" destOrd="0" presId="urn:microsoft.com/office/officeart/2005/8/layout/process4"/>
+    <dgm:cxn modelId="{9525AF2D-29FE-1443-977E-387D34C49A2C}" type="presParOf" srcId="{37ED7664-A217-EC44-8335-0637AF09792E}" destId="{7C08FC82-A0B2-8546-9BEE-D11B023CC0E0}" srcOrd="0" destOrd="0" presId="urn:microsoft.com/office/officeart/2005/8/layout/process4"/>
+    <dgm:cxn modelId="{21333A73-FC7C-BC4F-8D24-26AD27180209}" type="presParOf" srcId="{9AF84F5C-9FBF-1347-A3F0-1AAB8D6B7E6E}" destId="{DB8B9CDC-C90B-B14A-B550-5A3BA182F7FF}" srcOrd="3" destOrd="0" presId="urn:microsoft.com/office/officeart/2005/8/layout/process4"/>
+    <dgm:cxn modelId="{EA55D97F-FBE7-0841-AE1B-393CD5D81329}" type="presParOf" srcId="{9AF84F5C-9FBF-1347-A3F0-1AAB8D6B7E6E}" destId="{AF6D1F64-9B7F-F94A-87EB-95B86D5D400A}" srcOrd="4" destOrd="0" presId="urn:microsoft.com/office/officeart/2005/8/layout/process4"/>
+    <dgm:cxn modelId="{C85657FB-E85B-9A4B-9C69-0D5BFFF7E317}" type="presParOf" srcId="{AF6D1F64-9B7F-F94A-87EB-95B86D5D400A}" destId="{ED576AFA-79E4-BA45-A4C2-D3808209888F}" srcOrd="0" destOrd="0" presId="urn:microsoft.com/office/officeart/2005/8/layout/process4"/>
+    <dgm:cxn modelId="{9E74B1FE-4E9E-DA4B-959D-55E4628EDE19}" type="presParOf" srcId="{9AF84F5C-9FBF-1347-A3F0-1AAB8D6B7E6E}" destId="{6E90C472-88B4-4C4C-863B-0F37091D83E4}" srcOrd="5" destOrd="0" presId="urn:microsoft.com/office/officeart/2005/8/layout/process4"/>
+    <dgm:cxn modelId="{8BCFA3D5-3D0C-1B44-96DB-143CCE5F4097}" type="presParOf" srcId="{9AF84F5C-9FBF-1347-A3F0-1AAB8D6B7E6E}" destId="{7CE98043-0CA9-814C-B187-C76FD1E6666E}" srcOrd="6" destOrd="0" presId="urn:microsoft.com/office/officeart/2005/8/layout/process4"/>
+    <dgm:cxn modelId="{96BEA868-516D-0749-85AD-1280BFE0E372}" type="presParOf" srcId="{7CE98043-0CA9-814C-B187-C76FD1E6666E}" destId="{61A896E1-956C-764A-80FA-356EE9AC5E59}" srcOrd="0" destOrd="0" presId="urn:microsoft.com/office/officeart/2005/8/layout/process4"/>
+    <dgm:cxn modelId="{C11AD8AD-795C-E846-B55D-543A64F28CBF}" type="presParOf" srcId="{9AF84F5C-9FBF-1347-A3F0-1AAB8D6B7E6E}" destId="{C540290A-A5DE-6B44-B234-DF81AD15D0B6}" srcOrd="7" destOrd="0" presId="urn:microsoft.com/office/officeart/2005/8/layout/process4"/>
+    <dgm:cxn modelId="{8CE55736-FA67-5B4A-9BB3-1D9878687DBB}" type="presParOf" srcId="{9AF84F5C-9FBF-1347-A3F0-1AAB8D6B7E6E}" destId="{128A6F93-9B6A-DC4F-AFE7-0B84010DC784}" srcOrd="8" destOrd="0" presId="urn:microsoft.com/office/officeart/2005/8/layout/process4"/>
+    <dgm:cxn modelId="{50DE274B-9A84-6C48-8C9E-325A7F842AB1}" type="presParOf" srcId="{128A6F93-9B6A-DC4F-AFE7-0B84010DC784}" destId="{AAA1BBA0-2B9E-8244-A74D-6F23DD7EF9B1}" srcOrd="0" destOrd="0" presId="urn:microsoft.com/office/officeart/2005/8/layout/process4"/>
+    <dgm:cxn modelId="{F7819665-E2DB-C748-8E23-A85A58A7E09B}" type="presParOf" srcId="{9AF84F5C-9FBF-1347-A3F0-1AAB8D6B7E6E}" destId="{262EB433-C931-2145-82CF-82609B0D405D}" srcOrd="9" destOrd="0" presId="urn:microsoft.com/office/officeart/2005/8/layout/process4"/>
+    <dgm:cxn modelId="{0D088567-E29A-2642-9094-242C25858AF1}" type="presParOf" srcId="{9AF84F5C-9FBF-1347-A3F0-1AAB8D6B7E6E}" destId="{8DEFD305-6867-8744-A984-1CB4A871BCC6}" srcOrd="10" destOrd="0" presId="urn:microsoft.com/office/officeart/2005/8/layout/process4"/>
+    <dgm:cxn modelId="{32EB8693-52A8-0747-B80A-D3473DB49EBB}" type="presParOf" srcId="{8DEFD305-6867-8744-A984-1CB4A871BCC6}" destId="{6A9EE9A2-B242-924B-A517-EBFEDAE9CA00}" srcOrd="0" destOrd="0" presId="urn:microsoft.com/office/officeart/2005/8/layout/process4"/>
+  </dgm:cxnLst>
+  <dgm:bg/>
+  <dgm:whole/>
+  <dgm:extLst>
+    <a:ext uri="http://schemas.microsoft.com/office/drawing/2008/diagram">
+      <dsp:dataModelExt xmlns:dsp="http://schemas.microsoft.com/office/drawing/2008/diagram" relId="rId6" minVer="http://schemas.openxmlformats.org/drawingml/2006/diagram"/>
+    </a:ext>
+  </dgm:extLst>
+</dgm:dataModel>
+</file>
+
+<file path=ppt/diagrams/drawing1.xml><?xml version="1.0" encoding="utf-8"?>
+<dsp:drawing xmlns:dgm="http://schemas.openxmlformats.org/drawingml/2006/diagram" xmlns:dsp="http://schemas.microsoft.com/office/drawing/2008/diagram" xmlns:a="http://schemas.openxmlformats.org/drawingml/2006/main">
+  <dsp:spTree>
+    <dsp:nvGrpSpPr>
+      <dsp:cNvPr id="0" name=""/>
+      <dsp:cNvGrpSpPr/>
+    </dsp:nvGrpSpPr>
+    <dsp:grpSpPr/>
+    <dsp:sp modelId="{84A64D2F-A115-D844-BDA7-4425F5129A0C}">
+      <dsp:nvSpPr>
+        <dsp:cNvPr id="0" name=""/>
+        <dsp:cNvSpPr/>
+      </dsp:nvSpPr>
+      <dsp:spPr>
+        <a:xfrm>
+          <a:off x="0" y="4787718"/>
+          <a:ext cx="8128000" cy="628385"/>
+        </a:xfrm>
+        <a:prstGeom prst="rect">
+          <a:avLst/>
+        </a:prstGeom>
+        <a:solidFill>
+          <a:schemeClr val="lt1">
+            <a:hueOff val="0"/>
+            <a:satOff val="0"/>
+            <a:lumOff val="0"/>
+            <a:alphaOff val="0"/>
+          </a:schemeClr>
+        </a:solidFill>
+        <a:ln w="19050" cap="flat" cmpd="sng" algn="ctr">
+          <a:solidFill>
+            <a:schemeClr val="dk1">
+              <a:shade val="80000"/>
+              <a:hueOff val="0"/>
+              <a:satOff val="0"/>
+              <a:lumOff val="0"/>
+              <a:alphaOff val="0"/>
+            </a:schemeClr>
+          </a:solidFill>
+          <a:prstDash val="solid"/>
+          <a:miter lim="800000"/>
+        </a:ln>
+        <a:effectLst/>
+      </dsp:spPr>
+      <dsp:style>
+        <a:lnRef idx="2">
+          <a:scrgbClr r="0" g="0" b="0"/>
+        </a:lnRef>
+        <a:fillRef idx="1">
+          <a:scrgbClr r="0" g="0" b="0"/>
+        </a:fillRef>
+        <a:effectRef idx="0">
+          <a:scrgbClr r="0" g="0" b="0"/>
+        </a:effectRef>
+        <a:fontRef idx="minor">
+          <a:schemeClr val="lt1"/>
+        </a:fontRef>
+      </dsp:style>
+      <dsp:txBody>
+        <a:bodyPr spcFirstLastPara="0" vert="horz" wrap="square" lIns="227584" tIns="227584" rIns="227584" bIns="227584" numCol="1" spcCol="1270" anchor="ctr" anchorCtr="0">
+          <a:noAutofit/>
+        </a:bodyPr>
+        <a:lstStyle/>
+        <a:p>
+          <a:pPr marL="0" lvl="0" indent="0" algn="ctr" defTabSz="1422400">
+            <a:lnSpc>
+              <a:spcPct val="90000"/>
+            </a:lnSpc>
+            <a:spcBef>
+              <a:spcPct val="0"/>
+            </a:spcBef>
+            <a:spcAft>
+              <a:spcPct val="35000"/>
+            </a:spcAft>
+            <a:buNone/>
+          </a:pPr>
+          <a:r>
+            <a:rPr kumimoji="1" lang="ja-JP" altLang="en-US" sz="3200" b="1" i="0" kern="1200">
+              <a:latin typeface="Hiragino Sans W8" panose="020B0400000000000000" pitchFamily="34" charset="-128"/>
+              <a:ea typeface="Hiragino Sans W8" panose="020B0400000000000000" pitchFamily="34" charset="-128"/>
+            </a:rPr>
+            <a:t>経済成長阻害</a:t>
+          </a:r>
+        </a:p>
+      </dsp:txBody>
+      <dsp:txXfrm>
+        <a:off x="0" y="4787718"/>
+        <a:ext cx="8128000" cy="628385"/>
+      </dsp:txXfrm>
+    </dsp:sp>
+    <dsp:sp modelId="{7C08FC82-A0B2-8546-9BEE-D11B023CC0E0}">
+      <dsp:nvSpPr>
+        <dsp:cNvPr id="0" name=""/>
+        <dsp:cNvSpPr/>
+      </dsp:nvSpPr>
+      <dsp:spPr>
+        <a:xfrm rot="10800000">
+          <a:off x="0" y="3830687"/>
+          <a:ext cx="8128000" cy="966456"/>
+        </a:xfrm>
+        <a:prstGeom prst="upArrowCallout">
+          <a:avLst/>
+        </a:prstGeom>
+        <a:solidFill>
+          <a:schemeClr val="lt1">
+            <a:hueOff val="0"/>
+            <a:satOff val="0"/>
+            <a:lumOff val="0"/>
+            <a:alphaOff val="0"/>
+          </a:schemeClr>
+        </a:solidFill>
+        <a:ln w="19050" cap="flat" cmpd="sng" algn="ctr">
+          <a:solidFill>
+            <a:schemeClr val="dk1">
+              <a:shade val="80000"/>
+              <a:hueOff val="0"/>
+              <a:satOff val="0"/>
+              <a:lumOff val="0"/>
+              <a:alphaOff val="0"/>
+            </a:schemeClr>
+          </a:solidFill>
+          <a:prstDash val="solid"/>
+          <a:miter lim="800000"/>
+        </a:ln>
+        <a:effectLst/>
+      </dsp:spPr>
+      <dsp:style>
+        <a:lnRef idx="2">
+          <a:scrgbClr r="0" g="0" b="0"/>
+        </a:lnRef>
+        <a:fillRef idx="1">
+          <a:scrgbClr r="0" g="0" b="0"/>
+        </a:fillRef>
+        <a:effectRef idx="0">
+          <a:scrgbClr r="0" g="0" b="0"/>
+        </a:effectRef>
+        <a:fontRef idx="minor">
+          <a:schemeClr val="lt1"/>
+        </a:fontRef>
+      </dsp:style>
+      <dsp:txBody>
+        <a:bodyPr spcFirstLastPara="0" vert="horz" wrap="square" lIns="227584" tIns="227584" rIns="227584" bIns="227584" numCol="1" spcCol="1270" anchor="ctr" anchorCtr="0">
+          <a:noAutofit/>
+        </a:bodyPr>
+        <a:lstStyle/>
+        <a:p>
+          <a:pPr marL="0" lvl="0" indent="0" algn="ctr" defTabSz="1422400">
+            <a:lnSpc>
+              <a:spcPct val="90000"/>
+            </a:lnSpc>
+            <a:spcBef>
+              <a:spcPct val="0"/>
+            </a:spcBef>
+            <a:spcAft>
+              <a:spcPct val="35000"/>
+            </a:spcAft>
+            <a:buNone/>
+          </a:pPr>
+          <a:r>
+            <a:rPr kumimoji="1" lang="ja-JP" altLang="en-US" sz="3200" b="1" i="0" kern="1200">
+              <a:latin typeface="Hiragino Sans W8" panose="020B0400000000000000" pitchFamily="34" charset="-128"/>
+              <a:ea typeface="Hiragino Sans W8" panose="020B0400000000000000" pitchFamily="34" charset="-128"/>
+            </a:rPr>
+            <a:t>輸出阻害</a:t>
+          </a:r>
+          <a:endParaRPr kumimoji="1" lang="ja-JP" altLang="en-US" sz="2000" b="1" i="0" kern="1200">
+            <a:latin typeface="Hiragino Sans W8" panose="020B0400000000000000" pitchFamily="34" charset="-128"/>
+            <a:ea typeface="Hiragino Sans W8" panose="020B0400000000000000" pitchFamily="34" charset="-128"/>
+          </a:endParaRPr>
+        </a:p>
+      </dsp:txBody>
+      <dsp:txXfrm rot="10800000">
+        <a:off x="0" y="3830687"/>
+        <a:ext cx="8128000" cy="627974"/>
+      </dsp:txXfrm>
+    </dsp:sp>
+    <dsp:sp modelId="{ED576AFA-79E4-BA45-A4C2-D3808209888F}">
+      <dsp:nvSpPr>
+        <dsp:cNvPr id="0" name=""/>
+        <dsp:cNvSpPr/>
+      </dsp:nvSpPr>
+      <dsp:spPr>
+        <a:xfrm rot="10800000">
+          <a:off x="0" y="2873656"/>
+          <a:ext cx="8128000" cy="966456"/>
+        </a:xfrm>
+        <a:prstGeom prst="upArrowCallout">
+          <a:avLst/>
+        </a:prstGeom>
+        <a:solidFill>
+          <a:schemeClr val="lt1">
+            <a:hueOff val="0"/>
+            <a:satOff val="0"/>
+            <a:lumOff val="0"/>
+            <a:alphaOff val="0"/>
+          </a:schemeClr>
+        </a:solidFill>
+        <a:ln w="19050" cap="flat" cmpd="sng" algn="ctr">
+          <a:solidFill>
+            <a:schemeClr val="dk1">
+              <a:shade val="80000"/>
+              <a:hueOff val="0"/>
+              <a:satOff val="0"/>
+              <a:lumOff val="0"/>
+              <a:alphaOff val="0"/>
+            </a:schemeClr>
+          </a:solidFill>
+          <a:prstDash val="solid"/>
+          <a:miter lim="800000"/>
+        </a:ln>
+        <a:effectLst/>
+      </dsp:spPr>
+      <dsp:style>
+        <a:lnRef idx="2">
+          <a:scrgbClr r="0" g="0" b="0"/>
+        </a:lnRef>
+        <a:fillRef idx="1">
+          <a:scrgbClr r="0" g="0" b="0"/>
+        </a:fillRef>
+        <a:effectRef idx="0">
+          <a:scrgbClr r="0" g="0" b="0"/>
+        </a:effectRef>
+        <a:fontRef idx="minor">
+          <a:schemeClr val="lt1"/>
+        </a:fontRef>
+      </dsp:style>
+      <dsp:txBody>
+        <a:bodyPr spcFirstLastPara="0" vert="horz" wrap="square" lIns="227584" tIns="227584" rIns="227584" bIns="227584" numCol="1" spcCol="1270" anchor="ctr" anchorCtr="0">
+          <a:noAutofit/>
+        </a:bodyPr>
+        <a:lstStyle/>
+        <a:p>
+          <a:pPr marL="0" lvl="0" indent="0" algn="ctr" defTabSz="1422400">
+            <a:lnSpc>
+              <a:spcPct val="90000"/>
+            </a:lnSpc>
+            <a:spcBef>
+              <a:spcPct val="0"/>
+            </a:spcBef>
+            <a:spcAft>
+              <a:spcPct val="35000"/>
+            </a:spcAft>
+            <a:buNone/>
+          </a:pPr>
+          <a:r>
+            <a:rPr kumimoji="1" lang="ja-JP" altLang="en-US" sz="3200" b="1" i="0" kern="1200">
+              <a:latin typeface="Hiragino Sans W8" panose="020B0400000000000000" pitchFamily="34" charset="-128"/>
+              <a:ea typeface="Hiragino Sans W8" panose="020B0400000000000000" pitchFamily="34" charset="-128"/>
+            </a:rPr>
+            <a:t>通貨増価</a:t>
+          </a:r>
+        </a:p>
+      </dsp:txBody>
+      <dsp:txXfrm rot="10800000">
+        <a:off x="0" y="2873656"/>
+        <a:ext cx="8128000" cy="627974"/>
+      </dsp:txXfrm>
+    </dsp:sp>
+    <dsp:sp modelId="{61A896E1-956C-764A-80FA-356EE9AC5E59}">
+      <dsp:nvSpPr>
+        <dsp:cNvPr id="0" name=""/>
+        <dsp:cNvSpPr/>
+      </dsp:nvSpPr>
+      <dsp:spPr>
+        <a:xfrm rot="10800000">
+          <a:off x="0" y="1916625"/>
+          <a:ext cx="8128000" cy="966456"/>
+        </a:xfrm>
+        <a:prstGeom prst="upArrowCallout">
+          <a:avLst/>
+        </a:prstGeom>
+        <a:solidFill>
+          <a:schemeClr val="lt1">
+            <a:hueOff val="0"/>
+            <a:satOff val="0"/>
+            <a:lumOff val="0"/>
+            <a:alphaOff val="0"/>
+          </a:schemeClr>
+        </a:solidFill>
+        <a:ln w="19050" cap="flat" cmpd="sng" algn="ctr">
+          <a:solidFill>
+            <a:schemeClr val="dk1">
+              <a:shade val="80000"/>
+              <a:hueOff val="0"/>
+              <a:satOff val="0"/>
+              <a:lumOff val="0"/>
+              <a:alphaOff val="0"/>
+            </a:schemeClr>
+          </a:solidFill>
+          <a:prstDash val="solid"/>
+          <a:miter lim="800000"/>
+        </a:ln>
+        <a:effectLst/>
+      </dsp:spPr>
+      <dsp:style>
+        <a:lnRef idx="2">
+          <a:scrgbClr r="0" g="0" b="0"/>
+        </a:lnRef>
+        <a:fillRef idx="1">
+          <a:scrgbClr r="0" g="0" b="0"/>
+        </a:fillRef>
+        <a:effectRef idx="0">
+          <a:scrgbClr r="0" g="0" b="0"/>
+        </a:effectRef>
+        <a:fontRef idx="minor">
+          <a:schemeClr val="lt1"/>
+        </a:fontRef>
+      </dsp:style>
+      <dsp:txBody>
+        <a:bodyPr spcFirstLastPara="0" vert="horz" wrap="square" lIns="227584" tIns="227584" rIns="227584" bIns="227584" numCol="1" spcCol="1270" anchor="ctr" anchorCtr="0">
+          <a:noAutofit/>
+        </a:bodyPr>
+        <a:lstStyle/>
+        <a:p>
+          <a:pPr marL="0" lvl="0" indent="0" algn="ctr" defTabSz="1422400">
+            <a:lnSpc>
+              <a:spcPct val="90000"/>
+            </a:lnSpc>
+            <a:spcBef>
+              <a:spcPct val="0"/>
+            </a:spcBef>
+            <a:spcAft>
+              <a:spcPct val="35000"/>
+            </a:spcAft>
+            <a:buNone/>
+          </a:pPr>
+          <a:r>
+            <a:rPr kumimoji="1" lang="ja-JP" altLang="en-US" sz="3200" b="1" i="0" kern="1200">
+              <a:latin typeface="Hiragino Sans W8" panose="020B0400000000000000" pitchFamily="34" charset="-128"/>
+              <a:ea typeface="Hiragino Sans W8" panose="020B0400000000000000" pitchFamily="34" charset="-128"/>
+            </a:rPr>
+            <a:t>金融引き締め</a:t>
+          </a:r>
+        </a:p>
+      </dsp:txBody>
+      <dsp:txXfrm rot="10800000">
+        <a:off x="0" y="1916625"/>
+        <a:ext cx="8128000" cy="627974"/>
+      </dsp:txXfrm>
+    </dsp:sp>
+    <dsp:sp modelId="{AAA1BBA0-2B9E-8244-A74D-6F23DD7EF9B1}">
+      <dsp:nvSpPr>
+        <dsp:cNvPr id="0" name=""/>
+        <dsp:cNvSpPr/>
+      </dsp:nvSpPr>
+      <dsp:spPr>
+        <a:xfrm rot="10800000">
+          <a:off x="0" y="959594"/>
+          <a:ext cx="8128000" cy="966456"/>
+        </a:xfrm>
+        <a:prstGeom prst="upArrowCallout">
+          <a:avLst/>
+        </a:prstGeom>
+        <a:solidFill>
+          <a:schemeClr val="lt1">
+            <a:hueOff val="0"/>
+            <a:satOff val="0"/>
+            <a:lumOff val="0"/>
+            <a:alphaOff val="0"/>
+          </a:schemeClr>
+        </a:solidFill>
+        <a:ln w="19050" cap="flat" cmpd="sng" algn="ctr">
+          <a:solidFill>
+            <a:schemeClr val="dk1">
+              <a:shade val="80000"/>
+              <a:hueOff val="0"/>
+              <a:satOff val="0"/>
+              <a:lumOff val="0"/>
+              <a:alphaOff val="0"/>
+            </a:schemeClr>
+          </a:solidFill>
+          <a:prstDash val="solid"/>
+          <a:miter lim="800000"/>
+        </a:ln>
+        <a:effectLst/>
+      </dsp:spPr>
+      <dsp:style>
+        <a:lnRef idx="2">
+          <a:scrgbClr r="0" g="0" b="0"/>
+        </a:lnRef>
+        <a:fillRef idx="1">
+          <a:scrgbClr r="0" g="0" b="0"/>
+        </a:fillRef>
+        <a:effectRef idx="0">
+          <a:scrgbClr r="0" g="0" b="0"/>
+        </a:effectRef>
+        <a:fontRef idx="minor">
+          <a:schemeClr val="lt1"/>
+        </a:fontRef>
+      </dsp:style>
+      <dsp:txBody>
+        <a:bodyPr spcFirstLastPara="0" vert="horz" wrap="square" lIns="227584" tIns="227584" rIns="227584" bIns="227584" numCol="1" spcCol="1270" anchor="ctr" anchorCtr="0">
+          <a:noAutofit/>
+        </a:bodyPr>
+        <a:lstStyle/>
+        <a:p>
+          <a:pPr marL="0" lvl="0" indent="0" algn="ctr" defTabSz="1422400">
+            <a:lnSpc>
+              <a:spcPct val="90000"/>
+            </a:lnSpc>
+            <a:spcBef>
+              <a:spcPct val="0"/>
+            </a:spcBef>
+            <a:spcAft>
+              <a:spcPct val="35000"/>
+            </a:spcAft>
+            <a:buNone/>
+          </a:pPr>
+          <a:r>
+            <a:rPr kumimoji="1" lang="ja-JP" altLang="en-US" sz="3200" b="1" i="0" kern="1200">
+              <a:latin typeface="Hiragino Sans W8" panose="020B0400000000000000" pitchFamily="34" charset="-128"/>
+              <a:ea typeface="Hiragino Sans W8" panose="020B0400000000000000" pitchFamily="34" charset="-128"/>
+            </a:rPr>
+            <a:t>インフレ</a:t>
+          </a:r>
+        </a:p>
+      </dsp:txBody>
+      <dsp:txXfrm rot="10800000">
+        <a:off x="0" y="959594"/>
+        <a:ext cx="8128000" cy="627974"/>
+      </dsp:txXfrm>
+    </dsp:sp>
+    <dsp:sp modelId="{6A9EE9A2-B242-924B-A517-EBFEDAE9CA00}">
+      <dsp:nvSpPr>
+        <dsp:cNvPr id="0" name=""/>
+        <dsp:cNvSpPr/>
+      </dsp:nvSpPr>
+      <dsp:spPr>
+        <a:xfrm rot="10800000">
+          <a:off x="0" y="2563"/>
+          <a:ext cx="8128000" cy="966456"/>
+        </a:xfrm>
+        <a:prstGeom prst="upArrowCallout">
+          <a:avLst/>
+        </a:prstGeom>
+        <a:solidFill>
+          <a:schemeClr val="lt1">
+            <a:hueOff val="0"/>
+            <a:satOff val="0"/>
+            <a:lumOff val="0"/>
+            <a:alphaOff val="0"/>
+          </a:schemeClr>
+        </a:solidFill>
+        <a:ln w="19050" cap="flat" cmpd="sng" algn="ctr">
+          <a:solidFill>
+            <a:schemeClr val="dk1">
+              <a:shade val="80000"/>
+              <a:hueOff val="0"/>
+              <a:satOff val="0"/>
+              <a:lumOff val="0"/>
+              <a:alphaOff val="0"/>
+            </a:schemeClr>
+          </a:solidFill>
+          <a:prstDash val="solid"/>
+          <a:miter lim="800000"/>
+        </a:ln>
+        <a:effectLst/>
+      </dsp:spPr>
+      <dsp:style>
+        <a:lnRef idx="2">
+          <a:scrgbClr r="0" g="0" b="0"/>
+        </a:lnRef>
+        <a:fillRef idx="1">
+          <a:scrgbClr r="0" g="0" b="0"/>
+        </a:fillRef>
+        <a:effectRef idx="0">
+          <a:scrgbClr r="0" g="0" b="0"/>
+        </a:effectRef>
+        <a:fontRef idx="minor">
+          <a:schemeClr val="lt1"/>
+        </a:fontRef>
+      </dsp:style>
+      <dsp:txBody>
+        <a:bodyPr spcFirstLastPara="0" vert="horz" wrap="square" lIns="227584" tIns="227584" rIns="227584" bIns="227584" numCol="1" spcCol="1270" anchor="ctr" anchorCtr="0">
+          <a:noAutofit/>
+        </a:bodyPr>
+        <a:lstStyle/>
+        <a:p>
+          <a:pPr marL="0" lvl="0" indent="0" algn="ctr" defTabSz="1422400">
+            <a:lnSpc>
+              <a:spcPct val="90000"/>
+            </a:lnSpc>
+            <a:spcBef>
+              <a:spcPct val="0"/>
+            </a:spcBef>
+            <a:spcAft>
+              <a:spcPct val="35000"/>
+            </a:spcAft>
+            <a:buNone/>
+          </a:pPr>
+          <a:r>
+            <a:rPr kumimoji="1" lang="ja-JP" altLang="en-US" sz="3200" b="1" i="0" kern="1200">
+              <a:latin typeface="Hiragino Sans W7" panose="020B0400000000000000" pitchFamily="34" charset="-128"/>
+              <a:ea typeface="Hiragino Sans W7" panose="020B0400000000000000" pitchFamily="34" charset="-128"/>
+            </a:rPr>
+            <a:t>財政支出の</a:t>
+          </a:r>
+          <a:r>
+            <a:rPr kumimoji="1" lang="ja-JP" altLang="en-US" sz="3200" b="1" i="0" kern="1200">
+              <a:latin typeface="Hiragino Sans W8" panose="020B0400000000000000" pitchFamily="34" charset="-128"/>
+              <a:ea typeface="Hiragino Sans W8" panose="020B0400000000000000" pitchFamily="34" charset="-128"/>
+            </a:rPr>
+            <a:t>拡大</a:t>
+          </a:r>
+        </a:p>
+      </dsp:txBody>
+      <dsp:txXfrm rot="10800000">
+        <a:off x="0" y="2563"/>
+        <a:ext cx="8128000" cy="627974"/>
+      </dsp:txXfrm>
+    </dsp:sp>
+  </dsp:spTree>
+</dsp:drawing>
+</file>
+
+<file path=ppt/diagrams/layout1.xml><?xml version="1.0" encoding="utf-8"?>
+<dgm:layoutDef xmlns:dgm="http://schemas.openxmlformats.org/drawingml/2006/diagram" xmlns:a="http://schemas.openxmlformats.org/drawingml/2006/main" uniqueId="urn:microsoft.com/office/officeart/2005/8/layout/process4">
+  <dgm:title val=""/>
+  <dgm:desc val=""/>
+  <dgm:catLst>
+    <dgm:cat type="process" pri="16000"/>
+    <dgm:cat type="list" pri="20000"/>
+  </dgm:catLst>
+  <dgm:sampData>
+    <dgm:dataModel>
+      <dgm:ptLst>
+        <dgm:pt modelId="0" type="doc"/>
+        <dgm:pt modelId="1">
+          <dgm:prSet phldr="1"/>
+        </dgm:pt>
+        <dgm:pt modelId="11">
+          <dgm:prSet phldr="1"/>
+        </dgm:pt>
+        <dgm:pt modelId="12">
+          <dgm:prSet phldr="1"/>
+        </dgm:pt>
+        <dgm:pt modelId="2">
+          <dgm:prSet phldr="1"/>
+        </dgm:pt>
+        <dgm:pt modelId="21">
+          <dgm:prSet phldr="1"/>
+        </dgm:pt>
+        <dgm:pt modelId="22">
+          <dgm:prSet phldr="1"/>
+        </dgm:pt>
+        <dgm:pt modelId="3">
+          <dgm:prSet phldr="1"/>
+        </dgm:pt>
+        <dgm:pt modelId="31">
+          <dgm:prSet phldr="1"/>
+        </dgm:pt>
+        <dgm:pt modelId="32">
+          <dgm:prSet phldr="1"/>
+        </dgm:pt>
+      </dgm:ptLst>
+      <dgm:cxnLst>
+        <dgm:cxn modelId="4" srcId="0" destId="1" srcOrd="0" destOrd="0"/>
+        <dgm:cxn modelId="5" srcId="0" destId="2" srcOrd="1" destOrd="0"/>
+        <dgm:cxn modelId="6" srcId="0" destId="3" srcOrd="2" destOrd="0"/>
+        <dgm:cxn modelId="13" srcId="1" destId="11" srcOrd="0" destOrd="0"/>
+        <dgm:cxn modelId="14" srcId="1" destId="12" srcOrd="1" destOrd="0"/>
+        <dgm:cxn modelId="23" srcId="2" destId="21" srcOrd="0" destOrd="0"/>
+        <dgm:cxn modelId="24" srcId="2" destId="22" srcOrd="1" destOrd="0"/>
+        <dgm:cxn modelId="33" srcId="3" destId="31" srcOrd="0" destOrd="0"/>
+        <dgm:cxn modelId="34" srcId="3" destId="32" srcOrd="1" destOrd="0"/>
+      </dgm:cxnLst>
+      <dgm:bg/>
+      <dgm:whole/>
+    </dgm:dataModel>
+  </dgm:sampData>
+  <dgm:styleData>
+    <dgm:dataModel>
+      <dgm:ptLst>
+        <dgm:pt modelId="0" type="doc"/>
+        <dgm:pt modelId="1"/>
+        <dgm:pt modelId="11"/>
+        <dgm:pt modelId="2"/>
+        <dgm:pt modelId="21"/>
+      </dgm:ptLst>
+      <dgm:cxnLst>
+        <dgm:cxn modelId="4" srcId="0" destId="1" srcOrd="0" destOrd="0"/>
+        <dgm:cxn modelId="5" srcId="0" destId="2" srcOrd="1" destOrd="0"/>
+        <dgm:cxn modelId="13" srcId="1" destId="11" srcOrd="0" destOrd="0"/>
+        <dgm:cxn modelId="23" srcId="2" destId="21" srcOrd="0" destOrd="0"/>
+      </dgm:cxnLst>
+      <dgm:bg/>
+      <dgm:whole/>
+    </dgm:dataModel>
+  </dgm:styleData>
+  <dgm:clrData>
+    <dgm:dataModel>
+      <dgm:ptLst>
+        <dgm:pt modelId="0" type="doc"/>
+        <dgm:pt modelId="1"/>
+        <dgm:pt modelId="11"/>
+        <dgm:pt modelId="2"/>
+        <dgm:pt modelId="21"/>
+        <dgm:pt modelId="3"/>
+        <dgm:pt modelId="31"/>
+        <dgm:pt modelId="4"/>
+        <dgm:pt modelId="41"/>
+      </dgm:ptLst>
+      <dgm:cxnLst>
+        <dgm:cxn modelId="5" srcId="0" destId="1" srcOrd="0" destOrd="0"/>
+        <dgm:cxn modelId="6" srcId="0" destId="2" srcOrd="1" destOrd="0"/>
+        <dgm:cxn modelId="7" srcId="0" destId="3" srcOrd="2" destOrd="0"/>
+        <dgm:cxn modelId="8" srcId="0" destId="4" srcOrd="3" destOrd="0"/>
+        <dgm:cxn modelId="13" srcId="1" destId="11" srcOrd="0" destOrd="0"/>
+        <dgm:cxn modelId="23" srcId="2" destId="21" srcOrd="0" destOrd="0"/>
+        <dgm:cxn modelId="33" srcId="3" destId="31" srcOrd="0" destOrd="0"/>
+        <dgm:cxn modelId="43" srcId="4" destId="41" srcOrd="0" destOrd="0"/>
+      </dgm:cxnLst>
+      <dgm:bg/>
+      <dgm:whole/>
+    </dgm:dataModel>
+  </dgm:clrData>
+  <dgm:layoutNode name="Name0">
+    <dgm:varLst>
+      <dgm:dir/>
+      <dgm:animLvl val="lvl"/>
+      <dgm:resizeHandles val="exact"/>
+    </dgm:varLst>
+    <dgm:alg type="lin">
+      <dgm:param type="linDir" val="fromB"/>
+    </dgm:alg>
+    <dgm:shape xmlns:r="http://schemas.openxmlformats.org/officeDocument/2006/relationships" r:blip="">
+      <dgm:adjLst/>
+    </dgm:shape>
+    <dgm:presOf/>
+    <dgm:constrLst>
+      <dgm:constr type="h" for="ch" forName="boxAndChildren" refType="h"/>
+      <dgm:constr type="h" for="ch" forName="arrowAndChildren" refType="h" refFor="ch" refForName="boxAndChildren" op="equ" fact="1.538"/>
+      <dgm:constr type="w" for="ch" forName="arrowAndChildren" refType="w"/>
+      <dgm:constr type="w" for="ch" forName="boxAndChildren" refType="w"/>
+      <dgm:constr type="h" for="ch" forName="sp" refType="h" fact="-0.015"/>
+      <dgm:constr type="primFontSz" for="des" forName="parentTextBox" val="65"/>
+      <dgm:constr type="primFontSz" for="des" forName="parentTextArrow" refType="primFontSz" refFor="des" refForName="parentTextBox" op="equ"/>
+      <dgm:constr type="primFontSz" for="des" forName="childTextArrow" val="65"/>
+      <dgm:constr type="primFontSz" for="des" forName="childTextBox" refType="primFontSz" refFor="des" refForName="childTextArrow" op="equ"/>
+    </dgm:constrLst>
+    <dgm:ruleLst/>
+    <dgm:forEach name="Name1" axis="ch" ptType="node" st="-1" step="-1">
+      <dgm:choose name="Name2">
+        <dgm:if name="Name3" axis="self" ptType="node" func="revPos" op="equ" val="1">
+          <dgm:layoutNode name="boxAndChildren">
+            <dgm:alg type="composite"/>
+            <dgm:shape xmlns:r="http://schemas.openxmlformats.org/officeDocument/2006/relationships" r:blip="">
+              <dgm:adjLst/>
+            </dgm:shape>
+            <dgm:presOf/>
+            <dgm:choose name="Name4">
+              <dgm:if name="Name5" axis="ch" ptType="node" func="cnt" op="gte" val="1">
+                <dgm:constrLst>
+                  <dgm:constr type="w" for="ch" forName="parentTextBox" refType="w"/>
+                  <dgm:constr type="h" for="ch" forName="parentTextBox" refType="h" fact="0.54"/>
+                  <dgm:constr type="t" for="ch" forName="parentTextBox"/>
+                  <dgm:constr type="w" for="ch" forName="entireBox" refType="w"/>
+                  <dgm:constr type="h" for="ch" forName="entireBox" refType="h"/>
+                  <dgm:constr type="w" for="ch" forName="descendantBox" refType="w"/>
+                  <dgm:constr type="b" for="ch" forName="descendantBox" refType="h" fact="0.98"/>
+                  <dgm:constr type="h" for="ch" forName="descendantBox" refType="h" fact="0.46"/>
+                </dgm:constrLst>
+              </dgm:if>
+              <dgm:else name="Name6">
+                <dgm:constrLst>
+                  <dgm:constr type="w" for="ch" forName="parentTextBox" refType="w"/>
+                  <dgm:constr type="h" for="ch" forName="parentTextBox" refType="h"/>
+                </dgm:constrLst>
+              </dgm:else>
+            </dgm:choose>
+            <dgm:ruleLst/>
+            <dgm:layoutNode name="parentTextBox">
+              <dgm:alg type="tx"/>
+              <dgm:choose name="Name7">
+                <dgm:if name="Name8" axis="ch" ptType="node" func="cnt" op="gte" val="1">
+                  <dgm:shape xmlns:r="http://schemas.openxmlformats.org/officeDocument/2006/relationships" type="rect" r:blip="" zOrderOff="1" hideGeom="1">
+                    <dgm:adjLst/>
+                  </dgm:shape>
+                </dgm:if>
+                <dgm:else name="Name9">
+                  <dgm:shape xmlns:r="http://schemas.openxmlformats.org/officeDocument/2006/relationships" type="rect" r:blip="">
+                    <dgm:adjLst/>
+                  </dgm:shape>
+                </dgm:else>
+              </dgm:choose>
+              <dgm:presOf axis="self"/>
+              <dgm:constrLst/>
+              <dgm:ruleLst>
+                <dgm:rule type="primFontSz" val="5" fact="NaN" max="NaN"/>
+              </dgm:ruleLst>
+            </dgm:layoutNode>
+            <dgm:choose name="Name10">
+              <dgm:if name="Name11" axis="ch" ptType="node" func="cnt" op="gte" val="1">
+                <dgm:layoutNode name="entireBox">
+                  <dgm:alg type="sp"/>
+                  <dgm:shape xmlns:r="http://schemas.openxmlformats.org/officeDocument/2006/relationships" type="rect" r:blip="">
+                    <dgm:adjLst/>
+                  </dgm:shape>
+                  <dgm:presOf axis="self"/>
+                  <dgm:constrLst/>
+                  <dgm:ruleLst/>
+                </dgm:layoutNode>
+                <dgm:layoutNode name="descendantBox" styleLbl="fgAccFollowNode1">
+                  <dgm:choose name="Name12">
+                    <dgm:if name="Name13" func="var" arg="dir" op="equ" val="norm">
+                      <dgm:alg type="lin"/>
+                    </dgm:if>
+                    <dgm:else name="Name14">
+                      <dgm:alg type="lin">
+                        <dgm:param type="linDir" val="fromR"/>
+                      </dgm:alg>
+                    </dgm:else>
+                  </dgm:choose>
+                  <dgm:shape xmlns:r="http://schemas.openxmlformats.org/officeDocument/2006/relationships" r:blip="">
+                    <dgm:adjLst/>
+                  </dgm:shape>
+                  <dgm:presOf/>
+                  <dgm:constrLst>
+                    <dgm:constr type="w" for="ch" forName="childTextBox" refType="w"/>
+                    <dgm:constr type="h" for="ch" forName="childTextBox" refType="h"/>
+                  </dgm:constrLst>
+                  <dgm:ruleLst/>
+                  <dgm:forEach name="Name15" axis="ch" ptType="node">
+                    <dgm:layoutNode name="childTextBox" styleLbl="fgAccFollowNode1">
+                      <dgm:varLst>
+                        <dgm:bulletEnabled val="1"/>
+                      </dgm:varLst>
+                      <dgm:alg type="tx"/>
+                      <dgm:shape xmlns:r="http://schemas.openxmlformats.org/officeDocument/2006/relationships" type="rect" r:blip="">
+                        <dgm:adjLst/>
+                      </dgm:shape>
+                      <dgm:presOf axis="desOrSelf" ptType="node"/>
+                      <dgm:constrLst>
+                        <dgm:constr type="tMarg" refType="primFontSz" fact="0.1"/>
+                        <dgm:constr type="bMarg" refType="primFontSz" fact="0.1"/>
+                      </dgm:constrLst>
+                      <dgm:ruleLst>
+                        <dgm:rule type="primFontSz" val="5" fact="NaN" max="NaN"/>
+                      </dgm:ruleLst>
+                    </dgm:layoutNode>
+                  </dgm:forEach>
+                </dgm:layoutNode>
+              </dgm:if>
+              <dgm:else name="Name16"/>
+            </dgm:choose>
+          </dgm:layoutNode>
+        </dgm:if>
+        <dgm:else name="Name17">
+          <dgm:layoutNode name="arrowAndChildren">
+            <dgm:alg type="composite"/>
+            <dgm:shape xmlns:r="http://schemas.openxmlformats.org/officeDocument/2006/relationships" r:blip="">
+              <dgm:adjLst/>
+            </dgm:shape>
+            <dgm:presOf/>
+            <dgm:choose name="Name18">
+              <dgm:if name="Name19" axis="ch" ptType="node" func="cnt" op="gte" val="1">
+                <dgm:constrLst>
+                  <dgm:constr type="w" for="ch" forName="parentTextArrow" refType="w"/>
+                  <dgm:constr type="t" for="ch" forName="parentTextArrow"/>
+                  <dgm:constr type="h" for="ch" forName="parentTextArrow" refType="h" fact="0.351"/>
+                  <dgm:constr type="w" for="ch" forName="arrow" refType="w"/>
+                  <dgm:constr type="h" for="ch" forName="arrow" refType="h"/>
+                  <dgm:constr type="w" for="ch" forName="descendantArrow" refType="w"/>
+                  <dgm:constr type="b" for="ch" forName="descendantArrow" refType="h" fact="0.65"/>
+                  <dgm:constr type="h" for="ch" forName="descendantArrow" refType="h" fact="0.299"/>
+                </dgm:constrLst>
+              </dgm:if>
+              <dgm:else name="Name20">
+                <dgm:constrLst>
+                  <dgm:constr type="w" for="ch" forName="parentTextArrow" refType="w"/>
+                  <dgm:constr type="h" for="ch" forName="parentTextArrow" refType="h"/>
+                </dgm:constrLst>
+              </dgm:else>
+            </dgm:choose>
+            <dgm:ruleLst/>
+            <dgm:layoutNode name="parentTextArrow">
+              <dgm:alg type="tx"/>
+              <dgm:choose name="Name21">
+                <dgm:if name="Name22" axis="ch" ptType="node" func="cnt" op="gte" val="1">
+                  <dgm:shape xmlns:r="http://schemas.openxmlformats.org/officeDocument/2006/relationships" type="rect" r:blip="" zOrderOff="1" hideGeom="1">
+                    <dgm:adjLst/>
+                  </dgm:shape>
+                </dgm:if>
+                <dgm:else name="Name23">
+                  <dgm:shape xmlns:r="http://schemas.openxmlformats.org/officeDocument/2006/relationships" rot="180" type="upArrowCallout" r:blip="">
+                    <dgm:adjLst/>
+                  </dgm:shape>
+                </dgm:else>
+              </dgm:choose>
+              <dgm:presOf axis="self"/>
+              <dgm:constrLst/>
+              <dgm:ruleLst>
+                <dgm:rule type="primFontSz" val="5" fact="NaN" max="NaN"/>
+              </dgm:ruleLst>
+            </dgm:layoutNode>
+            <dgm:choose name="Name24">
+              <dgm:if name="Name25" axis="ch" ptType="node" func="cnt" op="gte" val="1">
+                <dgm:layoutNode name="arrow">
+                  <dgm:alg type="sp"/>
+                  <dgm:shape xmlns:r="http://schemas.openxmlformats.org/officeDocument/2006/relationships" rot="180" type="upArrowCallout" r:blip="">
+                    <dgm:adjLst/>
+                  </dgm:shape>
+                  <dgm:presOf axis="self"/>
+                  <dgm:constrLst/>
+                  <dgm:ruleLst/>
+                </dgm:layoutNode>
+                <dgm:layoutNode name="descendantArrow">
+                  <dgm:choose name="Name26">
+                    <dgm:if name="Name27" func="var" arg="dir" op="equ" val="norm">
+                      <dgm:alg type="lin"/>
+                    </dgm:if>
+                    <dgm:else name="Name28">
+                      <dgm:alg type="lin">
+                        <dgm:param type="linDir" val="fromR"/>
+                      </dgm:alg>
+                    </dgm:else>
+                  </dgm:choose>
+                  <dgm:shape xmlns:r="http://schemas.openxmlformats.org/officeDocument/2006/relationships" r:blip="">
+                    <dgm:adjLst/>
+                  </dgm:shape>
+                  <dgm:presOf/>
+                  <dgm:constrLst>
+                    <dgm:constr type="w" for="ch" forName="childTextArrow" refType="w"/>
+                    <dgm:constr type="h" for="ch" forName="childTextArrow" refType="h"/>
+                  </dgm:constrLst>
+                  <dgm:ruleLst/>
+                  <dgm:forEach name="Name29" axis="ch" ptType="node">
+                    <dgm:layoutNode name="childTextArrow" styleLbl="fgAccFollowNode1">
+                      <dgm:varLst>
+                        <dgm:bulletEnabled val="1"/>
+                      </dgm:varLst>
+                      <dgm:alg type="tx"/>
+                      <dgm:shape xmlns:r="http://schemas.openxmlformats.org/officeDocument/2006/relationships" type="rect" r:blip="">
+                        <dgm:adjLst/>
+                      </dgm:shape>
+                      <dgm:presOf axis="desOrSelf" ptType="node"/>
+                      <dgm:constrLst>
+                        <dgm:constr type="tMarg" refType="primFontSz" fact="0.1"/>
+                        <dgm:constr type="bMarg" refType="primFontSz" fact="0.1"/>
+                      </dgm:constrLst>
+                      <dgm:ruleLst>
+                        <dgm:rule type="primFontSz" val="5" fact="NaN" max="NaN"/>
+                      </dgm:ruleLst>
+                    </dgm:layoutNode>
+                  </dgm:forEach>
+                </dgm:layoutNode>
+              </dgm:if>
+              <dgm:else name="Name30"/>
+            </dgm:choose>
+          </dgm:layoutNode>
+        </dgm:else>
+      </dgm:choose>
+      <dgm:forEach name="Name31" axis="precedSib" ptType="sibTrans" st="-1" cnt="1">
+        <dgm:layoutNode name="sp">
+          <dgm:alg type="sp"/>
+          <dgm:shape xmlns:r="http://schemas.openxmlformats.org/officeDocument/2006/relationships" r:blip="">
+            <dgm:adjLst/>
+          </dgm:shape>
+          <dgm:presOf axis="self"/>
+          <dgm:constrLst/>
+          <dgm:ruleLst/>
+        </dgm:layoutNode>
+      </dgm:forEach>
+    </dgm:forEach>
+  </dgm:layoutNode>
+</dgm:layoutDef>
+</file>
+
+<file path=ppt/diagrams/quickStyle1.xml><?xml version="1.0" encoding="utf-8"?>
+<dgm:styleDef xmlns:dgm="http://schemas.openxmlformats.org/drawingml/2006/diagram" xmlns:a="http://schemas.openxmlformats.org/drawingml/2006/main" uniqueId="urn:microsoft.com/office/officeart/2005/8/quickstyle/simple1">
+  <dgm:title val=""/>
+  <dgm:desc val=""/>
+  <dgm:catLst>
+    <dgm:cat type="simple" pri="10100"/>
+  </dgm:catLst>
+  <dgm:scene3d>
+    <a:camera prst="orthographicFront"/>
+    <a:lightRig rig="threePt" dir="t"/>
+  </dgm:scene3d>
+  <dgm:styleLbl name="node0">
+    <dgm:scene3d>
+      <a:camera prst="orthographicFront"/>
+      <a:lightRig rig="threePt" dir="t"/>
+    </dgm:scene3d>
+    <dgm:sp3d/>
+    <dgm:txPr/>
+    <dgm:style>
+      <a:lnRef idx="2">
+        <a:scrgbClr r="0" g="0" b="0"/>
+      </a:lnRef>
+      <a:fillRef idx="1">
+        <a:scrgbClr r="0" g="0" b="0"/>
+      </a:fillRef>
+      <a:effectRef idx="0">
+        <a:scrgbClr r="0" g="0" b="0"/>
+      </a:effectRef>
+      <a:fontRef idx="minor">
+        <a:schemeClr val="lt1"/>
+      </a:fontRef>
+    </dgm:style>
+  </dgm:styleLbl>
+  <dgm:styleLbl name="node0NoLn">
+    <dgm:scene3d>
+      <a:camera prst="orthographicFront"/>
+      <a:lightRig rig="threePt" dir="t"/>
+    </dgm:scene3d>
+    <dgm:sp3d/>
+    <dgm:txPr/>
+    <dgm:style>
+      <a:lnRef idx="1">
+        <a:scrgbClr r="0" g="0" b="0"/>
+      </a:lnRef>
+      <a:fillRef idx="1">
+        <a:scrgbClr r="0" g="0" b="0"/>
+      </a:fillRef>
+      <a:effectRef idx="0">
+        <a:scrgbClr r="0" g="0" b="0"/>
+      </a:effectRef>
+      <a:fontRef idx="minor">
+        <a:schemeClr val="lt1"/>
+      </a:fontRef>
+    </dgm:style>
+  </dgm:styleLbl>
+  <dgm:styleLbl name="lnNode1">
+    <dgm:scene3d>
+      <a:camera prst="orthographicFront"/>
+      <a:lightRig rig="threePt" dir="t"/>
+    </dgm:scene3d>
+    <dgm:sp3d/>
+    <dgm:txPr/>
+    <dgm:style>
+      <a:lnRef idx="2">
+        <a:scrgbClr r="0" g="0" b="0"/>
+      </a:lnRef>
+      <a:fillRef idx="1">
+        <a:scrgbClr r="0" g="0" b="0"/>
+      </a:fillRef>
+      <a:effectRef idx="0">
+        <a:scrgbClr r="0" g="0" b="0"/>
+      </a:effectRef>
+      <a:fontRef idx="minor">
+        <a:schemeClr val="lt1"/>
+      </a:fontRef>
+    </dgm:style>
+  </dgm:styleLbl>
+  <dgm:styleLbl name="vennNode1">
+    <dgm:scene3d>
+      <a:camera prst="orthographicFront"/>
+      <a:lightRig rig="threePt" dir="t"/>
+    </dgm:scene3d>
+    <dgm:sp3d/>
+    <dgm:txPr/>
+    <dgm:style>
+      <a:lnRef idx="2">
+        <a:scrgbClr r="0" g="0" b="0"/>
+      </a:lnRef>
+      <a:fillRef idx="1">
+        <a:scrgbClr r="0" g="0" b="0"/>
+      </a:fillRef>
+      <a:effectRef idx="0">
+        <a:scrgbClr r="0" g="0" b="0"/>
+      </a:effectRef>
+      <a:fontRef idx="minor">
+        <a:schemeClr val="tx1"/>
+      </a:fontRef>
+    </dgm:style>
+  </dgm:styleLbl>
+  <dgm:styleLbl name="alignNode1">
+    <dgm:scene3d>
+      <a:camera prst="orthographicFront"/>
+      <a:lightRig rig="threePt" dir="t"/>
+    </dgm:scene3d>
+    <dgm:sp3d/>
+    <dgm:txPr/>
+    <dgm:style>
+      <a:lnRef idx="2">
+        <a:scrgbClr r="0" g="0" b="0"/>
+      </a:lnRef>
+      <a:fillRef idx="1">
+        <a:scrgbClr r="0" g="0" b="0"/>
+      </a:fillRef>
+      <a:effectRef idx="0">
+        <a:scrgbClr r="0" g="0" b="0"/>
+      </a:effectRef>
+      <a:fontRef idx="minor">
+        <a:schemeClr val="lt1"/>
+      </a:fontRef>
+    </dgm:style>
+  </dgm:styleLbl>
+  <dgm:styleLbl name="node1">
+    <dgm:scene3d>
+      <a:camera prst="orthographicFront"/>
+      <a:lightRig rig="threePt" dir="t"/>
+    </dgm:scene3d>
+    <dgm:sp3d/>
+    <dgm:txPr/>
+    <dgm:style>
+      <a:lnRef idx="2">
+        <a:scrgbClr r="0" g="0" b="0"/>
+      </a:lnRef>
+      <a:fillRef idx="1">
+        <a:scrgbClr r="0" g="0" b="0"/>
+      </a:fillRef>
+      <a:effectRef idx="0">
+        <a:scrgbClr r="0" g="0" b="0"/>
+      </a:effectRef>
+      <a:fontRef idx="minor">
+        <a:schemeClr val="lt1"/>
+      </a:fontRef>
+    </dgm:style>
+  </dgm:styleLbl>
+  <dgm:styleLbl name="node1NoLn">
+    <dgm:scene3d>
+      <a:camera prst="orthographicFront"/>
+      <a:lightRig rig="threePt" dir="t"/>
+    </dgm:scene3d>
+    <dgm:sp3d/>
+    <dgm:txPr/>
+    <dgm:style>
+      <a:lnRef idx="1">
+        <a:scrgbClr r="0" g="0" b="0"/>
+      </a:lnRef>
+      <a:fillRef idx="1">
+        <a:scrgbClr r="0" g="0" b="0"/>
+      </a:fillRef>
+      <a:effectRef idx="0">
+        <a:scrgbClr r="0" g="0" b="0"/>
+      </a:effectRef>
+      <a:fontRef idx="minor">
+        <a:schemeClr val="lt1"/>
+      </a:fontRef>
+    </dgm:style>
+  </dgm:styleLbl>
+  <dgm:styleLbl name="ltNode1NoLn">
+    <dgm:scene3d>
+      <a:camera prst="orthographicFront"/>
+      <a:lightRig rig="threePt" dir="t"/>
+    </dgm:scene3d>
+    <dgm:sp3d/>
+    <dgm:txPr/>
+    <dgm:style>
+      <a:lnRef idx="1">
+        <a:scrgbClr r="0" g="0" b="0"/>
+      </a:lnRef>
+      <a:fillRef idx="1">
+        <a:scrgbClr r="0" g="0" b="0"/>
+      </a:fillRef>
+      <a:effectRef idx="0">
+        <a:scrgbClr r="0" g="0" b="0"/>
+      </a:effectRef>
+      <a:fontRef idx="minor">
+        <a:schemeClr val="lt1"/>
+      </a:fontRef>
+    </dgm:style>
+  </dgm:styleLbl>
+  <dgm:styleLbl name="node2">
+    <dgm:scene3d>
+      <a:camera prst="orthographicFront"/>
+      <a:lightRig rig="threePt" dir="t"/>
+    </dgm:scene3d>
+    <dgm:sp3d/>
+    <dgm:txPr/>
+    <dgm:style>
+      <a:lnRef idx="2">
+        <a:scrgbClr r="0" g="0" b="0"/>
+      </a:lnRef>
+      <a:fillRef idx="1">
+        <a:scrgbClr r="0" g="0" b="0"/>
+      </a:fillRef>
+      <a:effectRef idx="0">
+        <a:scrgbClr r="0" g="0" b="0"/>
+      </a:effectRef>
+      <a:fontRef idx="minor">
+        <a:schemeClr val="lt1"/>
+      </a:fontRef>
+    </dgm:style>
+  </dgm:styleLbl>
+  <dgm:styleLbl name="node2NoLn">
+    <dgm:scene3d>
+      <a:camera prst="orthographicFront"/>
+      <a:lightRig rig="threePt" dir="t"/>
+    </dgm:scene3d>
+    <dgm:sp3d/>
+    <dgm:txPr/>
+    <dgm:style>
+      <a:lnRef idx="1">
+        <a:scrgbClr r="0" g="0" b="0"/>
+      </a:lnRef>
+      <a:fillRef idx="1">
+        <a:scrgbClr r="0" g="0" b="0"/>
+      </a:fillRef>
+      <a:effectRef idx="0">
+        <a:scrgbClr r="0" g="0" b="0"/>
+      </a:effectRef>
+      <a:fontRef idx="minor">
+        <a:schemeClr val="lt1"/>
+      </a:fontRef>
+    </dgm:style>
+  </dgm:styleLbl>
+  <dgm:styleLbl name="node3">
+    <dgm:scene3d>
+      <a:camera prst="orthographicFront"/>
+      <a:lightRig rig="threePt" dir="t"/>
+    </dgm:scene3d>
+    <dgm:sp3d/>
+    <dgm:txPr/>
+    <dgm:style>
+      <a:lnRef idx="2">
+        <a:scrgbClr r="0" g="0" b="0"/>
+      </a:lnRef>
+      <a:fillRef idx="1">
+        <a:scrgbClr r="0" g="0" b="0"/>
+      </a:fillRef>
+      <a:effectRef idx="0">
+        <a:scrgbClr r="0" g="0" b="0"/>
+      </a:effectRef>
+      <a:fontRef idx="minor">
+        <a:schemeClr val="lt1"/>
+      </a:fontRef>
+    </dgm:style>
+  </dgm:styleLbl>
+  <dgm:styleLbl name="node3NoLn">
+    <dgm:scene3d>
+      <a:camera prst="orthographicFront"/>
+      <a:lightRig rig="threePt" dir="t"/>
+    </dgm:scene3d>
+    <dgm:sp3d/>
+    <dgm:txPr/>
+    <dgm:style>
+      <a:lnRef idx="1">
+        <a:scrgbClr r="0" g="0" b="0"/>
+      </a:lnRef>
+      <a:fillRef idx="1">
+        <a:scrgbClr r="0" g="0" b="0"/>
+      </a:fillRef>
+      <a:effectRef idx="0">
+        <a:scrgbClr r="0" g="0" b="0"/>
+      </a:effectRef>
+      <a:fontRef idx="minor">
+        <a:schemeClr val="lt1"/>
+      </a:fontRef>
+    </dgm:style>
+  </dgm:styleLbl>
+  <dgm:styleLbl name="node4">
+    <dgm:scene3d>
+      <a:camera prst="orthographicFront"/>
+      <a:lightRig rig="threePt" dir="t"/>
+    </dgm:scene3d>
+    <dgm:sp3d/>
+    <dgm:txPr/>
+    <dgm:style>
+      <a:lnRef idx="2">
+        <a:scrgbClr r="0" g="0" b="0"/>
+      </a:lnRef>
+      <a:fillRef idx="1">
+        <a:scrgbClr r="0" g="0" b="0"/>
+      </a:fillRef>
+      <a:effectRef idx="0">
+        <a:scrgbClr r="0" g="0" b="0"/>
+      </a:effectRef>
+      <a:fontRef idx="minor">
+        <a:schemeClr val="lt1"/>
+      </a:fontRef>
+    </dgm:style>
+  </dgm:styleLbl>
+  <dgm:styleLbl name="node4NoLn">
+    <dgm:scene3d>
+      <a:camera prst="orthographicFront"/>
+      <a:lightRig rig="threePt" dir="t"/>
+    </dgm:scene3d>
+    <dgm:sp3d/>
+    <dgm:txPr/>
+    <dgm:style>
+      <a:lnRef idx="1">
+        <a:scrgbClr r="0" g="0" b="0"/>
+      </a:lnRef>
+      <a:fillRef idx="1">
+        <a:scrgbClr r="0" g="0" b="0"/>
+      </a:fillRef>
+      <a:effectRef idx="0">
+        <a:scrgbClr r="0" g="0" b="0"/>
+      </a:effectRef>
+      <a:fontRef idx="minor">
+        <a:schemeClr val="lt1"/>
+      </a:fontRef>
+    </dgm:style>
+  </dgm:styleLbl>
+  <dgm:styleLbl name="fgImgPlace1">
+    <dgm:scene3d>
+      <a:camera prst="orthographicFront"/>
+      <a:lightRig rig="threePt" dir="t"/>
+    </dgm:scene3d>
+    <dgm:sp3d/>
+    <dgm:txPr/>
+    <dgm:style>
+      <a:lnRef idx="2">
+        <a:scrgbClr r="0" g="0" b="0"/>
+      </a:lnRef>
+      <a:fillRef idx="1">
+        <a:scrgbClr r="0" g="0" b="0"/>
+      </a:fillRef>
+      <a:effectRef idx="0">
+        <a:scrgbClr r="0" g="0" b="0"/>
+      </a:effectRef>
+      <a:fontRef idx="minor"/>
+    </dgm:style>
+  </dgm:styleLbl>
+  <dgm:styleLbl name="alignImgPlace1">
+    <dgm:scene3d>
+      <a:camera prst="orthographicFront"/>
+      <a:lightRig rig="threePt" dir="t"/>
+    </dgm:scene3d>
+    <dgm:sp3d/>
+    <dgm:txPr/>
+    <dgm:style>
+      <a:lnRef idx="2">
+        <a:scrgbClr r="0" g="0" b="0"/>
+      </a:lnRef>
+      <a:fillRef idx="1">
+        <a:scrgbClr r="0" g="0" b="0"/>
+      </a:fillRef>
+      <a:effectRef idx="0">
+        <a:scrgbClr r="0" g="0" b="0"/>
+      </a:effectRef>
+      <a:fontRef idx="minor"/>
+    </dgm:style>
+  </dgm:styleLbl>
+  <dgm:styleLbl name="bgImgPlace1">
+    <dgm:scene3d>
+      <a:camera prst="orthographicFront"/>
+      <a:lightRig rig="threePt" dir="t"/>
+    </dgm:scene3d>
+    <dgm:sp3d/>
+    <dgm:txPr/>
+    <dgm:style>
+      <a:lnRef idx="2">
+        <a:scrgbClr r="0" g="0" b="0"/>
+      </a:lnRef>
+      <a:fillRef idx="1">
+        <a:scrgbClr r="0" g="0" b="0"/>
+      </a:fillRef>
+      <a:effectRef idx="0">
+        <a:scrgbClr r="0" g="0" b="0"/>
+      </a:effectRef>
+      <a:fontRef idx="minor"/>
+    </dgm:style>
+  </dgm:styleLbl>
+  <dgm:styleLbl name="sibTrans2D1">
+    <dgm:scene3d>
+      <a:camera prst="orthographicFront"/>
+      <a:lightRig rig="threePt" dir="t"/>
+    </dgm:scene3d>
+    <dgm:sp3d/>
+    <dgm:txPr/>
+    <dgm:style>
+      <a:lnRef idx="0">
+        <a:scrgbClr r="0" g="0" b="0"/>
+      </a:lnRef>
+      <a:fillRef idx="1">
+        <a:scrgbClr r="0" g="0" b="0"/>
+      </a:fillRef>
+      <a:effectRef idx="0">
+        <a:scrgbClr r="0" g="0" b="0"/>
+      </a:effectRef>
+      <a:fontRef idx="minor">
+        <a:schemeClr val="lt1"/>
+      </a:fontRef>
+    </dgm:style>
+  </dgm:styleLbl>
+  <dgm:styleLbl name="fgSibTrans2D1">
+    <dgm:scene3d>
+      <a:camera prst="orthographicFront"/>
+      <a:lightRig rig="threePt" dir="t"/>
+    </dgm:scene3d>
+    <dgm:sp3d/>
+    <dgm:txPr/>
+    <dgm:style>
+      <a:lnRef idx="0">
+        <a:scrgbClr r="0" g="0" b="0"/>
+      </a:lnRef>
+      <a:fillRef idx="1">
+        <a:scrgbClr r="0" g="0" b="0"/>
+      </a:fillRef>
+      <a:effectRef idx="0">
+        <a:scrgbClr r="0" g="0" b="0"/>
+      </a:effectRef>
+      <a:fontRef idx="minor">
+        <a:schemeClr val="lt1"/>
+      </a:fontRef>
+    </dgm:style>
+  </dgm:styleLbl>
+  <dgm:styleLbl name="bgSibTrans2D1">
+    <dgm:scene3d>
+      <a:camera prst="orthographicFront"/>
+      <a:lightRig rig="threePt" dir="t"/>
+    </dgm:scene3d>
+    <dgm:sp3d/>
+    <dgm:txPr/>
+    <dgm:style>
+      <a:lnRef idx="0">
+        <a:scrgbClr r="0" g="0" b="0"/>
+      </a:lnRef>
+      <a:fillRef idx="1">
+        <a:scrgbClr r="0" g="0" b="0"/>
+      </a:fillRef>
+      <a:effectRef idx="0">
+        <a:scrgbClr r="0" g="0" b="0"/>
+      </a:effectRef>
+      <a:fontRef idx="minor">
+        <a:schemeClr val="lt1"/>
+      </a:fontRef>
+    </dgm:style>
+  </dgm:styleLbl>
+  <dgm:styleLbl name="sibTrans1D1">
+    <dgm:scene3d>
+      <a:camera prst="orthographicFront"/>
+      <a:lightRig rig="threePt" dir="t"/>
+    </dgm:scene3d>
+    <dgm:sp3d/>
+    <dgm:txPr/>
+    <dgm:style>
+      <a:lnRef idx="1">
+        <a:scrgbClr r="0" g="0" b="0"/>
+      </a:lnRef>
+      <a:fillRef idx="0">
+        <a:scrgbClr r="0" g="0" b="0"/>
+      </a:fillRef>
+      <a:effectRef idx="0">
+        <a:scrgbClr r="0" g="0" b="0"/>
+      </a:effectRef>
+      <a:fontRef idx="minor"/>
+    </dgm:style>
+  </dgm:styleLbl>
+  <dgm:styleLbl name="callout">
+    <dgm:scene3d>
+      <a:camera prst="orthographicFront"/>
+      <a:lightRig rig="threePt" dir="t"/>
+    </dgm:scene3d>
+    <dgm:sp3d/>
+    <dgm:txPr/>
+    <dgm:style>
+      <a:lnRef idx="2">
+        <a:scrgbClr r="0" g="0" b="0"/>
+      </a:lnRef>
+      <a:fillRef idx="1">
+        <a:scrgbClr r="0" g="0" b="0"/>
+      </a:fillRef>
+      <a:effectRef idx="0">
+        <a:scrgbClr r="0" g="0" b="0"/>
+      </a:effectRef>
+      <a:fontRef idx="minor"/>
+    </dgm:style>
+  </dgm:styleLbl>
+  <dgm:styleLbl name="asst0">
+    <dgm:scene3d>
+      <a:camera prst="orthographicFront"/>
+      <a:lightRig rig="threePt" dir="t"/>
+    </dgm:scene3d>
+    <dgm:sp3d/>
+    <dgm:txPr/>
+    <dgm:style>
+      <a:lnRef idx="2">
+        <a:scrgbClr r="0" g="0" b="0"/>
+      </a:lnRef>
+      <a:fillRef idx="1">
+        <a:scrgbClr r="0" g="0" b="0"/>
+      </a:fillRef>
+      <a:effectRef idx="0">
+        <a:scrgbClr r="0" g="0" b="0"/>
+      </a:effectRef>
+      <a:fontRef idx="minor">
+        <a:schemeClr val="lt1"/>
+      </a:fontRef>
+    </dgm:style>
+  </dgm:styleLbl>
+  <dgm:styleLbl name="asst1">
+    <dgm:scene3d>
+      <a:camera prst="orthographicFront"/>
+      <a:lightRig rig="threePt" dir="t"/>
+    </dgm:scene3d>
+    <dgm:sp3d/>
+    <dgm:txPr/>
+    <dgm:style>
+      <a:lnRef idx="2">
+        <a:scrgbClr r="0" g="0" b="0"/>
+      </a:lnRef>
+      <a:fillRef idx="1">
+        <a:scrgbClr r="0" g="0" b="0"/>
+      </a:fillRef>
+      <a:effectRef idx="0">
+        <a:scrgbClr r="0" g="0" b="0"/>
+      </a:effectRef>
+      <a:fontRef idx="minor">
+        <a:schemeClr val="lt1"/>
+      </a:fontRef>
+    </dgm:style>
+  </dgm:styleLbl>
+  <dgm:styleLbl name="asst2">
+    <dgm:scene3d>
+      <a:camera prst="orthographicFront"/>
+      <a:lightRig rig="threePt" dir="t"/>
+    </dgm:scene3d>
+    <dgm:sp3d/>
+    <dgm:txPr/>
+    <dgm:style>
+      <a:lnRef idx="2">
+        <a:scrgbClr r="0" g="0" b="0"/>
+      </a:lnRef>
+      <a:fillRef idx="1">
+        <a:scrgbClr r="0" g="0" b="0"/>
+      </a:fillRef>
+      <a:effectRef idx="0">
+        <a:scrgbClr r="0" g="0" b="0"/>
+      </a:effectRef>
+      <a:fontRef idx="minor">
+        <a:schemeClr val="lt1"/>
+      </a:fontRef>
+    </dgm:style>
+  </dgm:styleLbl>
+  <dgm:styleLbl name="asst3">
+    <dgm:scene3d>
+      <a:camera prst="orthographicFront"/>
+      <a:lightRig rig="threePt" dir="t"/>
+    </dgm:scene3d>
+    <dgm:sp3d/>
+    <dgm:txPr/>
+    <dgm:style>
+      <a:lnRef idx="2">
+        <a:scrgbClr r="0" g="0" b="0"/>
+      </a:lnRef>
+      <a:fillRef idx="1">
+        <a:scrgbClr r="0" g="0" b="0"/>
+      </a:fillRef>
+      <a:effectRef idx="0">
+        <a:scrgbClr r="0" g="0" b="0"/>
+      </a:effectRef>
+      <a:fontRef idx="minor">
+        <a:schemeClr val="lt1"/>
+      </a:fontRef>
+    </dgm:style>
+  </dgm:styleLbl>
+  <dgm:styleLbl name="asst4">
+    <dgm:scene3d>
+      <a:camera prst="orthographicFront"/>
+      <a:lightRig rig="threePt" dir="t"/>
+    </dgm:scene3d>
+    <dgm:sp3d/>
+    <dgm:txPr/>
+    <dgm:style>
+      <a:lnRef idx="2">
+        <a:scrgbClr r="0" g="0" b="0"/>
+      </a:lnRef>
+      <a:fillRef idx="1">
+        <a:scrgbClr r="0" g="0" b="0"/>
+      </a:fillRef>
+      <a:effectRef idx="0">
+        <a:scrgbClr r="0" g="0" b="0"/>
+      </a:effectRef>
+      <a:fontRef idx="minor">
+        <a:schemeClr val="lt1"/>
+      </a:fontRef>
+    </dgm:style>
+  </dgm:styleLbl>
+  <dgm:styleLbl name="parChTrans2D1">
+    <dgm:scene3d>
+      <a:camera prst="orthographicFront"/>
+      <a:lightRig rig="threePt" dir="t"/>
+    </dgm:scene3d>
+    <dgm:sp3d/>
+    <dgm:txPr/>
+    <dgm:style>
+      <a:lnRef idx="2">
+        <a:scrgbClr r="0" g="0" b="0"/>
+      </a:lnRef>
+      <a:fillRef idx="1">
+        <a:scrgbClr r="0" g="0" b="0"/>
+      </a:fillRef>
+      <a:effectRef idx="0">
+        <a:scrgbClr r="0" g="0" b="0"/>
+      </a:effectRef>
+      <a:fontRef idx="minor">
+        <a:schemeClr val="lt1"/>
+      </a:fontRef>
+    </dgm:style>
+  </dgm:styleLbl>
+  <dgm:styleLbl name="parChTrans2D2">
+    <dgm:scene3d>
+      <a:camera prst="orthographicFront"/>
+      <a:lightRig rig="threePt" dir="t"/>
+    </dgm:scene3d>
+    <dgm:sp3d/>
+    <dgm:txPr/>
+    <dgm:style>
+      <a:lnRef idx="2">
+        <a:scrgbClr r="0" g="0" b="0"/>
+      </a:lnRef>
+      <a:fillRef idx="1">
+        <a:scrgbClr r="0" g="0" b="0"/>
+      </a:fillRef>
+      <a:effectRef idx="0">
+        <a:scrgbClr r="0" g="0" b="0"/>
+      </a:effectRef>
+      <a:fontRef idx="minor">
+        <a:schemeClr val="lt1"/>
+      </a:fontRef>
+    </dgm:style>
+  </dgm:styleLbl>
+  <dgm:styleLbl name="parChTrans2D3">
+    <dgm:scene3d>
+      <a:camera prst="orthographicFront"/>
+      <a:lightRig rig="threePt" dir="t"/>
+    </dgm:scene3d>
+    <dgm:sp3d/>
+    <dgm:txPr/>
+    <dgm:style>
+      <a:lnRef idx="2">
+        <a:scrgbClr r="0" g="0" b="0"/>
+      </a:lnRef>
+      <a:fillRef idx="1">
+        <a:scrgbClr r="0" g="0" b="0"/>
+      </a:fillRef>
+      <a:effectRef idx="0">
+        <a:scrgbClr r="0" g="0" b="0"/>
+      </a:effectRef>
+      <a:fontRef idx="minor">
+        <a:schemeClr val="lt1"/>
+      </a:fontRef>
+    </dgm:style>
+  </dgm:styleLbl>
+  <dgm:styleLbl name="parChTrans2D4">
+    <dgm:scene3d>
+      <a:camera prst="orthographicFront"/>
+      <a:lightRig rig="threePt" dir="t"/>
+    </dgm:scene3d>
+    <dgm:sp3d/>
+    <dgm:txPr/>
+    <dgm:style>
+      <a:lnRef idx="2">
+        <a:scrgbClr r="0" g="0" b="0"/>
+      </a:lnRef>
+      <a:fillRef idx="1">
+        <a:scrgbClr r="0" g="0" b="0"/>
+      </a:fillRef>
+      <a:effectRef idx="0">
+        <a:scrgbClr r="0" g="0" b="0"/>
+      </a:effectRef>
+      <a:fontRef idx="minor">
+        <a:schemeClr val="lt1"/>
+      </a:fontRef>
+    </dgm:style>
+  </dgm:styleLbl>
+  <dgm:styleLbl name="parChTrans1D1">
+    <dgm:scene3d>
+      <a:camera prst="orthographicFront"/>
+      <a:lightRig rig="threePt" dir="t"/>
+    </dgm:scene3d>
+    <dgm:sp3d/>
+    <dgm:txPr/>
+    <dgm:style>
+      <a:lnRef idx="2">
+        <a:scrgbClr r="0" g="0" b="0"/>
+      </a:lnRef>
+      <a:fillRef idx="0">
+        <a:scrgbClr r="0" g="0" b="0"/>
+      </a:fillRef>
+      <a:effectRef idx="0">
+        <a:scrgbClr r="0" g="0" b="0"/>
+      </a:effectRef>
+      <a:fontRef idx="minor"/>
+    </dgm:style>
+  </dgm:styleLbl>
+  <dgm:styleLbl name="parChTrans1D2">
+    <dgm:scene3d>
+      <a:camera prst="orthographicFront"/>
+      <a:lightRig rig="threePt" dir="t"/>
+    </dgm:scene3d>
+    <dgm:sp3d/>
+    <dgm:txPr/>
+    <dgm:style>
+      <a:lnRef idx="2">
+        <a:scrgbClr r="0" g="0" b="0"/>
+      </a:lnRef>
+      <a:fillRef idx="0">
+        <a:scrgbClr r="0" g="0" b="0"/>
+      </a:fillRef>
+      <a:effectRef idx="0">
+        <a:scrgbClr r="0" g="0" b="0"/>
+      </a:effectRef>
+      <a:fontRef idx="minor"/>
+    </dgm:style>
+  </dgm:styleLbl>
+  <dgm:styleLbl name="parChTrans1D3">
+    <dgm:scene3d>
+      <a:camera prst="orthographicFront"/>
+      <a:lightRig rig="threePt" dir="t"/>
+    </dgm:scene3d>
+    <dgm:sp3d/>
+    <dgm:txPr/>
+    <dgm:style>
+      <a:lnRef idx="2">
+        <a:scrgbClr r="0" g="0" b="0"/>
+      </a:lnRef>
+      <a:fillRef idx="0">
+        <a:scrgbClr r="0" g="0" b="0"/>
+      </a:fillRef>
+      <a:effectRef idx="0">
+        <a:scrgbClr r="0" g="0" b="0"/>
+      </a:effectRef>
+      <a:fontRef idx="minor"/>
+    </dgm:style>
+  </dgm:styleLbl>
+  <dgm:styleLbl name="parChTrans1D4">
+    <dgm:scene3d>
+      <a:camera prst="orthographicFront"/>
+      <a:lightRig rig="threePt" dir="t"/>
+    </dgm:scene3d>
+    <dgm:sp3d/>
+    <dgm:txPr/>
+    <dgm:style>
+      <a:lnRef idx="2">
+        <a:scrgbClr r="0" g="0" b="0"/>
+      </a:lnRef>
+      <a:fillRef idx="0">
+        <a:scrgbClr r="0" g="0" b="0"/>
+      </a:fillRef>
+      <a:effectRef idx="0">
+        <a:scrgbClr r="0" g="0" b="0"/>
+      </a:effectRef>
+      <a:fontRef idx="minor"/>
+    </dgm:style>
+  </dgm:styleLbl>
+  <dgm:styleLbl name="fgAcc1">
+    <dgm:scene3d>
+      <a:camera prst="orthographicFront"/>
+      <a:lightRig rig="threePt" dir="t"/>
+    </dgm:scene3d>
+    <dgm:sp3d/>
+    <dgm:txPr/>
+    <dgm:style>
+      <a:lnRef idx="2">
+        <a:scrgbClr r="0" g="0" b="0"/>
+      </a:lnRef>
+      <a:fillRef idx="1">
+        <a:scrgbClr r="0" g="0" b="0"/>
+      </a:fillRef>
+      <a:effectRef idx="0">
+        <a:scrgbClr r="0" g="0" b="0"/>
+      </a:effectRef>
+      <a:fontRef idx="minor"/>
+    </dgm:style>
+  </dgm:styleLbl>
+  <dgm:styleLbl name="conFgAcc1">
+    <dgm:scene3d>
+      <a:camera prst="orthographicFront"/>
+      <a:lightRig rig="threePt" dir="t"/>
+    </dgm:scene3d>
+    <dgm:sp3d/>
+    <dgm:txPr/>
+    <dgm:style>
+      <a:lnRef idx="2">
+        <a:scrgbClr r="0" g="0" b="0"/>
+      </a:lnRef>
+      <a:fillRef idx="1">
+        <a:scrgbClr r="0" g="0" b="0"/>
+      </a:fillRef>
+      <a:effectRef idx="0">
+        <a:scrgbClr r="0" g="0" b="0"/>
+      </a:effectRef>
+      <a:fontRef idx="minor"/>
+    </dgm:style>
+  </dgm:styleLbl>
+  <dgm:styleLbl name="alignAcc1">
+    <dgm:scene3d>
+      <a:camera prst="orthographicFront"/>
+      <a:lightRig rig="threePt" dir="t"/>
+    </dgm:scene3d>
+    <dgm:sp3d/>
+    <dgm:txPr/>
+    <dgm:style>
+      <a:lnRef idx="2">
+        <a:scrgbClr r="0" g="0" b="0"/>
+      </a:lnRef>
+      <a:fillRef idx="1">
+        <a:scrgbClr r="0" g="0" b="0"/>
+      </a:fillRef>
+      <a:effectRef idx="0">
+        <a:scrgbClr r="0" g="0" b="0"/>
+      </a:effectRef>
+      <a:fontRef idx="minor"/>
+    </dgm:style>
+  </dgm:styleLbl>
+  <dgm:styleLbl name="trAlignAcc1">
+    <dgm:scene3d>
+      <a:camera prst="orthographicFront"/>
+      <a:lightRig rig="threePt" dir="t"/>
+    </dgm:scene3d>
+    <dgm:sp3d/>
+    <dgm:txPr/>
+    <dgm:style>
+      <a:lnRef idx="1">
+        <a:scrgbClr r="0" g="0" b="0"/>
+      </a:lnRef>
+      <a:fillRef idx="1">
+        <a:scrgbClr r="0" g="0" b="0"/>
+      </a:fillRef>
+      <a:effectRef idx="0">
+        <a:scrgbClr r="0" g="0" b="0"/>
+      </a:effectRef>
+      <a:fontRef idx="minor"/>
+    </dgm:style>
+  </dgm:styleLbl>
+  <dgm:styleLbl name="bgAcc1">
+    <dgm:scene3d>
+      <a:camera prst="orthographicFront"/>
+      <a:lightRig rig="threePt" dir="t"/>
+    </dgm:scene3d>
+    <dgm:sp3d/>
+    <dgm:txPr/>
+    <dgm:style>
+      <a:lnRef idx="2">
+        <a:scrgbClr r="0" g="0" b="0"/>
+      </a:lnRef>
+      <a:fillRef idx="1">
+        <a:scrgbClr r="0" g="0" b="0"/>
+      </a:fillRef>
+      <a:effectRef idx="0">
+        <a:scrgbClr r="0" g="0" b="0"/>
+      </a:effectRef>
+      <a:fontRef idx="minor"/>
+    </dgm:style>
+  </dgm:styleLbl>
+  <dgm:styleLbl name="solidFgAcc1">
+    <dgm:scene3d>
+      <a:camera prst="orthographicFront"/>
+      <a:lightRig rig="threePt" dir="t"/>
+    </dgm:scene3d>
+    <dgm:sp3d/>
+    <dgm:txPr/>
+    <dgm:style>
+      <a:lnRef idx="2">
+        <a:scrgbClr r="0" g="0" b="0"/>
+      </a:lnRef>
+      <a:fillRef idx="1">
+        <a:scrgbClr r="0" g="0" b="0"/>
+      </a:fillRef>
+      <a:effectRef idx="0">
+        <a:scrgbClr r="0" g="0" b="0"/>
+      </a:effectRef>
+      <a:fontRef idx="minor"/>
+    </dgm:style>
+  </dgm:styleLbl>
+  <dgm:styleLbl name="solidAlignAcc1">
+    <dgm:scene3d>
+      <a:camera prst="orthographicFront"/>
+      <a:lightRig rig="threePt" dir="t"/>
+    </dgm:scene3d>
+    <dgm:sp3d/>
+    <dgm:txPr/>
+    <dgm:style>
+      <a:lnRef idx="2">
+        <a:scrgbClr r="0" g="0" b="0"/>
+      </a:lnRef>
+      <a:fillRef idx="1">
+        <a:scrgbClr r="0" g="0" b="0"/>
+      </a:fillRef>
+      <a:effectRef idx="0">
+        <a:scrgbClr r="0" g="0" b="0"/>
+      </a:effectRef>
+      <a:fontRef idx="minor"/>
+    </dgm:style>
+  </dgm:styleLbl>
+  <dgm:styleLbl name="solidBgAcc1">
+    <dgm:scene3d>
+      <a:camera prst="orthographicFront"/>
+      <a:lightRig rig="threePt" dir="t"/>
+    </dgm:scene3d>
+    <dgm:sp3d/>
+    <dgm:txPr/>
+    <dgm:style>
+      <a:lnRef idx="2">
+        <a:scrgbClr r="0" g="0" b="0"/>
+      </a:lnRef>
+      <a:fillRef idx="1">
+        <a:scrgbClr r="0" g="0" b="0"/>
+      </a:fillRef>
+      <a:effectRef idx="0">
+        <a:scrgbClr r="0" g="0" b="0"/>
+      </a:effectRef>
+      <a:fontRef idx="minor"/>
+    </dgm:style>
+  </dgm:styleLbl>
+  <dgm:styleLbl name="fgAccFollowNode1">
+    <dgm:scene3d>
+      <a:camera prst="orthographicFront"/>
+      <a:lightRig rig="threePt" dir="t"/>
+    </dgm:scene3d>
+    <dgm:sp3d/>
+    <dgm:txPr/>
+    <dgm:style>
+      <a:lnRef idx="2">
+        <a:scrgbClr r="0" g="0" b="0"/>
+      </a:lnRef>
+      <a:fillRef idx="1">
+        <a:scrgbClr r="0" g="0" b="0"/>
+      </a:fillRef>
+      <a:effectRef idx="0">
+        <a:scrgbClr r="0" g="0" b="0"/>
+      </a:effectRef>
+      <a:fontRef idx="minor"/>
+    </dgm:style>
+  </dgm:styleLbl>
+  <dgm:styleLbl name="alignAccFollowNode1">
+    <dgm:scene3d>
+      <a:camera prst="orthographicFront"/>
+      <a:lightRig rig="threePt" dir="t"/>
+    </dgm:scene3d>
+    <dgm:sp3d/>
+    <dgm:txPr/>
+    <dgm:style>
+      <a:lnRef idx="2">
+        <a:scrgbClr r="0" g="0" b="0"/>
+      </a:lnRef>
+      <a:fillRef idx="1">
+        <a:scrgbClr r="0" g="0" b="0"/>
+      </a:fillRef>
+      <a:effectRef idx="0">
+        <a:scrgbClr r="0" g="0" b="0"/>
+      </a:effectRef>
+      <a:fontRef idx="minor"/>
+    </dgm:style>
+  </dgm:styleLbl>
+  <dgm:styleLbl name="bgAccFollowNode1">
+    <dgm:scene3d>
+      <a:camera prst="orthographicFront"/>
+      <a:lightRig rig="threePt" dir="t"/>
+    </dgm:scene3d>
+    <dgm:sp3d/>
+    <dgm:txPr/>
+    <dgm:style>
+      <a:lnRef idx="2">
+        <a:scrgbClr r="0" g="0" b="0"/>
+      </a:lnRef>
+      <a:fillRef idx="1">
+        <a:scrgbClr r="0" g="0" b="0"/>
+      </a:fillRef>
+      <a:effectRef idx="0">
+        <a:scrgbClr r="0" g="0" b="0"/>
+      </a:effectRef>
+      <a:fontRef idx="minor"/>
+    </dgm:style>
+  </dgm:styleLbl>
+  <dgm:styleLbl name="fgAcc0">
+    <dgm:scene3d>
+      <a:camera prst="orthographicFront"/>
+      <a:lightRig rig="threePt" dir="t"/>
+    </dgm:scene3d>
+    <dgm:sp3d/>
+    <dgm:txPr/>
+    <dgm:style>
+      <a:lnRef idx="2">
+        <a:scrgbClr r="0" g="0" b="0"/>
+      </a:lnRef>
+      <a:fillRef idx="1">
+        <a:scrgbClr r="0" g="0" b="0"/>
+      </a:fillRef>
+      <a:effectRef idx="0">
+        <a:scrgbClr r="0" g="0" b="0"/>
+      </a:effectRef>
+      <a:fontRef idx="minor"/>
+    </dgm:style>
+  </dgm:styleLbl>
+  <dgm:styleLbl name="fgAcc2">
+    <dgm:scene3d>
+      <a:camera prst="orthographicFront"/>
+      <a:lightRig rig="threePt" dir="t"/>
+    </dgm:scene3d>
+    <dgm:sp3d/>
+    <dgm:txPr/>
+    <dgm:style>
+      <a:lnRef idx="2">
+        <a:scrgbClr r="0" g="0" b="0"/>
+      </a:lnRef>
+      <a:fillRef idx="1">
+        <a:scrgbClr r="0" g="0" b="0"/>
+      </a:fillRef>
+      <a:effectRef idx="0">
+        <a:scrgbClr r="0" g="0" b="0"/>
+      </a:effectRef>
+      <a:fontRef idx="minor"/>
+    </dgm:style>
+  </dgm:styleLbl>
+  <dgm:styleLbl name="fgAcc3">
+    <dgm:scene3d>
+      <a:camera prst="orthographicFront"/>
+      <a:lightRig rig="threePt" dir="t"/>
+    </dgm:scene3d>
+    <dgm:sp3d/>
+    <dgm:txPr/>
+    <dgm:style>
+      <a:lnRef idx="2">
+        <a:scrgbClr r="0" g="0" b="0"/>
+      </a:lnRef>
+      <a:fillRef idx="1">
+        <a:scrgbClr r="0" g="0" b="0"/>
+      </a:fillRef>
+      <a:effectRef idx="0">
+        <a:scrgbClr r="0" g="0" b="0"/>
+      </a:effectRef>
+      <a:fontRef idx="minor"/>
+    </dgm:style>
+  </dgm:styleLbl>
+  <dgm:styleLbl name="fgAcc4">
+    <dgm:scene3d>
+      <a:camera prst="orthographicFront"/>
+      <a:lightRig rig="threePt" dir="t"/>
+    </dgm:scene3d>
+    <dgm:sp3d/>
+    <dgm:txPr/>
+    <dgm:style>
+      <a:lnRef idx="2">
+        <a:scrgbClr r="0" g="0" b="0"/>
+      </a:lnRef>
+      <a:fillRef idx="1">
+        <a:scrgbClr r="0" g="0" b="0"/>
+      </a:fillRef>
+      <a:effectRef idx="0">
+        <a:scrgbClr r="0" g="0" b="0"/>
+      </a:effectRef>
+      <a:fontRef idx="minor"/>
+    </dgm:style>
+  </dgm:styleLbl>
+  <dgm:styleLbl name="bgShp">
+    <dgm:scene3d>
+      <a:camera prst="orthographicFront"/>
+      <a:lightRig rig="threePt" dir="t"/>
+    </dgm:scene3d>
+    <dgm:sp3d/>
+    <dgm:txPr/>
+    <dgm:style>
+      <a:lnRef idx="0">
+        <a:scrgbClr r="0" g="0" b="0"/>
+      </a:lnRef>
+      <a:fillRef idx="1">
+        <a:scrgbClr r="0" g="0" b="0"/>
+      </a:fillRef>
+      <a:effectRef idx="0">
+        <a:scrgbClr r="0" g="0" b="0"/>
+      </a:effectRef>
+      <a:fontRef idx="minor"/>
+    </dgm:style>
+  </dgm:styleLbl>
+  <dgm:styleLbl name="dkBgShp">
+    <dgm:scene3d>
+      <a:camera prst="orthographicFront"/>
+      <a:lightRig rig="threePt" dir="t"/>
+    </dgm:scene3d>
+    <dgm:sp3d/>
+    <dgm:txPr/>
+    <dgm:style>
+      <a:lnRef idx="0">
+        <a:scrgbClr r="0" g="0" b="0"/>
+      </a:lnRef>
+      <a:fillRef idx="1">
+        <a:scrgbClr r="0" g="0" b="0"/>
+      </a:fillRef>
+      <a:effectRef idx="0">
+        <a:scrgbClr r="0" g="0" b="0"/>
+      </a:effectRef>
+      <a:fontRef idx="minor"/>
+    </dgm:style>
+  </dgm:styleLbl>
+  <dgm:styleLbl name="trBgShp">
+    <dgm:scene3d>
+      <a:camera prst="orthographicFront"/>
+      <a:lightRig rig="threePt" dir="t"/>
+    </dgm:scene3d>
+    <dgm:sp3d/>
+    <dgm:txPr/>
+    <dgm:style>
+      <a:lnRef idx="0">
+        <a:scrgbClr r="0" g="0" b="0"/>
+      </a:lnRef>
+      <a:fillRef idx="1">
+        <a:scrgbClr r="0" g="0" b="0"/>
+      </a:fillRef>
+      <a:effectRef idx="0">
+        <a:scrgbClr r="0" g="0" b="0"/>
+      </a:effectRef>
+      <a:fontRef idx="minor"/>
+    </dgm:style>
+  </dgm:styleLbl>
+  <dgm:styleLbl name="fgShp">
+    <dgm:scene3d>
+      <a:camera prst="orthographicFront"/>
+      <a:lightRig rig="threePt" dir="t"/>
+    </dgm:scene3d>
+    <dgm:sp3d/>
+    <dgm:txPr/>
+    <dgm:style>
+      <a:lnRef idx="2">
+        <a:scrgbClr r="0" g="0" b="0"/>
+      </a:lnRef>
+      <a:fillRef idx="1">
+        <a:scrgbClr r="0" g="0" b="0"/>
+      </a:fillRef>
+      <a:effectRef idx="0">
+        <a:scrgbClr r="0" g="0" b="0"/>
+      </a:effectRef>
+      <a:fontRef idx="minor"/>
+    </dgm:style>
+  </dgm:styleLbl>
+  <dgm:styleLbl name="revTx">
+    <dgm:scene3d>
+      <a:camera prst="orthographicFront"/>
+      <a:lightRig rig="threePt" dir="t"/>
+    </dgm:scene3d>
+    <dgm:sp3d/>
+    <dgm:txPr/>
+    <dgm:style>
+      <a:lnRef idx="0">
+        <a:scrgbClr r="0" g="0" b="0"/>
+      </a:lnRef>
+      <a:fillRef idx="0">
+        <a:scrgbClr r="0" g="0" b="0"/>
+      </a:fillRef>
+      <a:effectRef idx="0">
+        <a:scrgbClr r="0" g="0" b="0"/>
+      </a:effectRef>
+      <a:fontRef idx="minor"/>
+    </dgm:style>
+  </dgm:styleLbl>
+  <dgm:styleLbl name="revTxLt">
+    <dgm:scene3d>
+      <a:camera prst="orthographicFront"/>
+      <a:lightRig rig="threePt" dir="t"/>
+    </dgm:scene3d>
+    <dgm:sp3d/>
+    <dgm:txPr/>
+    <dgm:style>
+      <a:lnRef idx="0">
+        <a:scrgbClr r="0" g="0" b="0"/>
+      </a:lnRef>
+      <a:fillRef idx="0">
+        <a:scrgbClr r="0" g="0" b="0"/>
+      </a:fillRef>
+      <a:effectRef idx="0">
+        <a:scrgbClr r="0" g="0" b="0"/>
+      </a:effectRef>
+      <a:fontRef idx="minor">
+        <a:schemeClr val="lt1"/>
+      </a:fontRef>
+    </dgm:style>
+  </dgm:styleLbl>
+</dgm:styleDef>
+</file>
+
 <file path=ppt/slideLayouts/slideLayout1.xml><?xml version="1.0" encoding="utf-8"?>
 <p:sldLayout xmlns:a="http://schemas.openxmlformats.org/drawingml/2006/main" xmlns:r="http://schemas.openxmlformats.org/officeDocument/2006/relationships" xmlns:p="http://schemas.openxmlformats.org/presentationml/2006/main" type="title" preserve="1">
   <p:cSld name="タイトル スライド">
@@ -260,7 +3578,7 @@
           <a:p>
             <a:fld id="{29D38AE0-A022-EC4B-ADED-C3987264F154}" type="datetimeFigureOut">
               <a:rPr kumimoji="1" lang="ja-JP" altLang="en-US" smtClean="0"/>
-              <a:t>2026/8/12</a:t>
+              <a:t>2026/9/15</a:t>
             </a:fld>
             <a:endParaRPr kumimoji="1" lang="ja-JP" altLang="en-US"/>
           </a:p>
@@ -490,7 +3808,7 @@
           <a:p>
             <a:fld id="{29D38AE0-A022-EC4B-ADED-C3987264F154}" type="datetimeFigureOut">
               <a:rPr kumimoji="1" lang="ja-JP" altLang="en-US" smtClean="0"/>
-              <a:t>2026/8/12</a:t>
+              <a:t>2026/9/15</a:t>
             </a:fld>
             <a:endParaRPr kumimoji="1" lang="ja-JP" altLang="en-US"/>
           </a:p>
@@ -730,7 +4048,7 @@
           <a:p>
             <a:fld id="{29D38AE0-A022-EC4B-ADED-C3987264F154}" type="datetimeFigureOut">
               <a:rPr kumimoji="1" lang="ja-JP" altLang="en-US" smtClean="0"/>
-              <a:t>2026/8/12</a:t>
+              <a:t>2026/9/15</a:t>
             </a:fld>
             <a:endParaRPr kumimoji="1" lang="ja-JP" altLang="en-US"/>
           </a:p>
@@ -960,7 +4278,7 @@
           <a:p>
             <a:fld id="{29D38AE0-A022-EC4B-ADED-C3987264F154}" type="datetimeFigureOut">
               <a:rPr kumimoji="1" lang="ja-JP" altLang="en-US" smtClean="0"/>
-              <a:t>2026/8/12</a:t>
+              <a:t>2026/9/15</a:t>
             </a:fld>
             <a:endParaRPr kumimoji="1" lang="ja-JP" altLang="en-US"/>
           </a:p>
@@ -1235,7 +4553,7 @@
           <a:p>
             <a:fld id="{29D38AE0-A022-EC4B-ADED-C3987264F154}" type="datetimeFigureOut">
               <a:rPr kumimoji="1" lang="ja-JP" altLang="en-US" smtClean="0"/>
-              <a:t>2026/8/12</a:t>
+              <a:t>2026/9/15</a:t>
             </a:fld>
             <a:endParaRPr kumimoji="1" lang="ja-JP" altLang="en-US"/>
           </a:p>
@@ -1564,7 +4882,7 @@
           <a:p>
             <a:fld id="{29D38AE0-A022-EC4B-ADED-C3987264F154}" type="datetimeFigureOut">
               <a:rPr kumimoji="1" lang="ja-JP" altLang="en-US" smtClean="0"/>
-              <a:t>2026/8/12</a:t>
+              <a:t>2026/9/15</a:t>
             </a:fld>
             <a:endParaRPr kumimoji="1" lang="ja-JP" altLang="en-US"/>
           </a:p>
@@ -2040,7 +5358,7 @@
           <a:p>
             <a:fld id="{29D38AE0-A022-EC4B-ADED-C3987264F154}" type="datetimeFigureOut">
               <a:rPr kumimoji="1" lang="ja-JP" altLang="en-US" smtClean="0"/>
-              <a:t>2026/8/12</a:t>
+              <a:t>2026/9/15</a:t>
             </a:fld>
             <a:endParaRPr kumimoji="1" lang="ja-JP" altLang="en-US"/>
           </a:p>
@@ -2181,7 +5499,7 @@
           <a:p>
             <a:fld id="{29D38AE0-A022-EC4B-ADED-C3987264F154}" type="datetimeFigureOut">
               <a:rPr kumimoji="1" lang="ja-JP" altLang="en-US" smtClean="0"/>
-              <a:t>2026/8/12</a:t>
+              <a:t>2026/9/15</a:t>
             </a:fld>
             <a:endParaRPr kumimoji="1" lang="ja-JP" altLang="en-US"/>
           </a:p>
@@ -2294,7 +5612,7 @@
           <a:p>
             <a:fld id="{29D38AE0-A022-EC4B-ADED-C3987264F154}" type="datetimeFigureOut">
               <a:rPr kumimoji="1" lang="ja-JP" altLang="en-US" smtClean="0"/>
-              <a:t>2026/8/12</a:t>
+              <a:t>2026/9/15</a:t>
             </a:fld>
             <a:endParaRPr kumimoji="1" lang="ja-JP" altLang="en-US"/>
           </a:p>
@@ -2637,7 +5955,7 @@
           <a:p>
             <a:fld id="{29D38AE0-A022-EC4B-ADED-C3987264F154}" type="datetimeFigureOut">
               <a:rPr kumimoji="1" lang="ja-JP" altLang="en-US" smtClean="0"/>
-              <a:t>2026/8/12</a:t>
+              <a:t>2026/9/15</a:t>
             </a:fld>
             <a:endParaRPr kumimoji="1" lang="ja-JP" altLang="en-US"/>
           </a:p>
@@ -2925,7 +6243,7 @@
           <a:p>
             <a:fld id="{29D38AE0-A022-EC4B-ADED-C3987264F154}" type="datetimeFigureOut">
               <a:rPr kumimoji="1" lang="ja-JP" altLang="en-US" smtClean="0"/>
-              <a:t>2026/8/12</a:t>
+              <a:t>2026/9/15</a:t>
             </a:fld>
             <a:endParaRPr kumimoji="1" lang="ja-JP" altLang="en-US"/>
           </a:p>
@@ -3198,7 +6516,7 @@
           <a:p>
             <a:fld id="{29D38AE0-A022-EC4B-ADED-C3987264F154}" type="datetimeFigureOut">
               <a:rPr kumimoji="1" lang="ja-JP" altLang="en-US" smtClean="0"/>
-              <a:t>2026/8/12</a:t>
+              <a:t>2026/9/15</a:t>
             </a:fld>
             <a:endParaRPr kumimoji="1" lang="ja-JP" altLang="en-US"/>
           </a:p>
@@ -7677,6 +10995,64 @@
 </p:sld>
 </file>
 
+<file path=ppt/slides/slide3.xml><?xml version="1.0" encoding="utf-8"?>
+<p:sld xmlns:a="http://schemas.openxmlformats.org/drawingml/2006/main" xmlns:r="http://schemas.openxmlformats.org/officeDocument/2006/relationships" xmlns:p="http://schemas.openxmlformats.org/presentationml/2006/main">
+  <p:cSld>
+    <p:spTree>
+      <p:nvGrpSpPr>
+        <p:cNvPr id="1" name=""/>
+        <p:cNvGrpSpPr/>
+        <p:nvPr/>
+      </p:nvGrpSpPr>
+      <p:grpSpPr>
+        <a:xfrm>
+          <a:off x="0" y="0"/>
+          <a:ext cx="0" cy="0"/>
+          <a:chOff x="0" y="0"/>
+          <a:chExt cx="0" cy="0"/>
+        </a:xfrm>
+      </p:grpSpPr>
+      <p:graphicFrame>
+        <p:nvGraphicFramePr>
+          <p:cNvPr id="3" name="図表 2">
+            <a:extLst>
+              <a:ext uri="{FF2B5EF4-FFF2-40B4-BE49-F238E27FC236}">
+                <a16:creationId xmlns:a16="http://schemas.microsoft.com/office/drawing/2014/main" id="{F87D0524-CF92-6C75-B773-5933268DC4AE}"/>
+              </a:ext>
+            </a:extLst>
+          </p:cNvPr>
+          <p:cNvGraphicFramePr/>
+          <p:nvPr>
+            <p:extLst>
+              <p:ext uri="{D42A27DB-BD31-4B8C-83A1-F6EECF244321}">
+                <p14:modId xmlns:p14="http://schemas.microsoft.com/office/powerpoint/2010/main" val="3821883171"/>
+              </p:ext>
+            </p:extLst>
+          </p:nvPr>
+        </p:nvGraphicFramePr>
+        <p:xfrm>
+          <a:off x="2032000" y="719666"/>
+          <a:ext cx="8128000" cy="5418667"/>
+        </p:xfrm>
+        <a:graphic>
+          <a:graphicData uri="http://schemas.openxmlformats.org/drawingml/2006/diagram">
+            <dgm:relIds xmlns:dgm="http://schemas.openxmlformats.org/drawingml/2006/diagram" xmlns:r="http://schemas.openxmlformats.org/officeDocument/2006/relationships" r:dm="rId2" r:lo="rId3" r:qs="rId4" r:cs="rId5"/>
+          </a:graphicData>
+        </a:graphic>
+      </p:graphicFrame>
+    </p:spTree>
+    <p:extLst>
+      <p:ext uri="{BB962C8B-B14F-4D97-AF65-F5344CB8AC3E}">
+        <p14:creationId xmlns:p14="http://schemas.microsoft.com/office/powerpoint/2010/main" val="2867660998"/>
+      </p:ext>
+    </p:extLst>
+  </p:cSld>
+  <p:clrMapOvr>
+    <a:masterClrMapping/>
+  </p:clrMapOvr>
+</p:sld>
+</file>
+
 <file path=ppt/theme/theme1.xml><?xml version="1.0" encoding="utf-8"?>
 <a:theme xmlns:a="http://schemas.openxmlformats.org/drawingml/2006/main" name="Office テーマ">
   <a:themeElements>

</xml_diff>

<commit_message>
Updated the syllabus and 01/Intro
</commit_message>
<xml_diff>
--- a/figs/DIYfigures_ipe2.pptx
+++ b/figs/DIYfigures_ipe2.pptx
@@ -115,7 +115,7 @@
 </file>
 
 <file path=ppt/diagrams/colors1.xml><?xml version="1.0" encoding="utf-8"?>
-<dgm:colorsDef xmlns:dgm="http://schemas.openxmlformats.org/drawingml/2006/diagram" xmlns:a="http://schemas.openxmlformats.org/drawingml/2006/main" uniqueId="urn:microsoft.com/office/officeart/2005/8/colors/accent0_1">
+<dgm:colorsDef xmlns:dgm="http://schemas.openxmlformats.org/drawingml/2006/diagram" xmlns:a="http://schemas.openxmlformats.org/drawingml/2006/main" uniqueId="urn:microsoft.com/office/officeart/2005/8/colors/accent0_1#1">
   <dgm:title val=""/>
   <dgm:desc val=""/>
   <dgm:catLst>
@@ -1041,7 +1041,7 @@
 <dgm:dataModel xmlns:dgm="http://schemas.openxmlformats.org/drawingml/2006/diagram" xmlns:a="http://schemas.openxmlformats.org/drawingml/2006/main">
   <dgm:ptLst>
     <dgm:pt modelId="{E6215070-95AD-E046-B635-485C3AB1168F}" type="doc">
-      <dgm:prSet loTypeId="urn:microsoft.com/office/officeart/2005/8/layout/process4" loCatId="" qsTypeId="urn:microsoft.com/office/officeart/2005/8/quickstyle/simple1" qsCatId="simple" csTypeId="urn:microsoft.com/office/officeart/2005/8/colors/accent0_1" csCatId="mainScheme" phldr="1"/>
+      <dgm:prSet loTypeId="urn:microsoft.com/office/officeart/2005/8/layout/process4" loCatId="" qsTypeId="urn:microsoft.com/office/officeart/2005/8/quickstyle/simple1#1" qsCatId="simple" csTypeId="urn:microsoft.com/office/officeart/2005/8/colors/accent0_1#1" csCatId="mainScheme" phldr="1"/>
       <dgm:spPr/>
     </dgm:pt>
     <dgm:pt modelId="{B446C157-7E71-A341-AE84-E3072807250C}">
@@ -2244,7 +2244,7 @@
 </file>
 
 <file path=ppt/diagrams/quickStyle1.xml><?xml version="1.0" encoding="utf-8"?>
-<dgm:styleDef xmlns:dgm="http://schemas.openxmlformats.org/drawingml/2006/diagram" xmlns:a="http://schemas.openxmlformats.org/drawingml/2006/main" uniqueId="urn:microsoft.com/office/officeart/2005/8/quickstyle/simple1">
+<dgm:styleDef xmlns:dgm="http://schemas.openxmlformats.org/drawingml/2006/diagram" xmlns:a="http://schemas.openxmlformats.org/drawingml/2006/main" uniqueId="urn:microsoft.com/office/officeart/2005/8/quickstyle/simple1#1">
   <dgm:title val=""/>
   <dgm:desc val=""/>
   <dgm:catLst>
@@ -3578,7 +3578,7 @@
           <a:p>
             <a:fld id="{29D38AE0-A022-EC4B-ADED-C3987264F154}" type="datetimeFigureOut">
               <a:rPr kumimoji="1" lang="ja-JP" altLang="en-US" smtClean="0"/>
-              <a:t>2026/9/15</a:t>
+              <a:t>2026/9/28</a:t>
             </a:fld>
             <a:endParaRPr kumimoji="1" lang="ja-JP" altLang="en-US"/>
           </a:p>
@@ -3808,7 +3808,7 @@
           <a:p>
             <a:fld id="{29D38AE0-A022-EC4B-ADED-C3987264F154}" type="datetimeFigureOut">
               <a:rPr kumimoji="1" lang="ja-JP" altLang="en-US" smtClean="0"/>
-              <a:t>2026/9/15</a:t>
+              <a:t>2026/9/28</a:t>
             </a:fld>
             <a:endParaRPr kumimoji="1" lang="ja-JP" altLang="en-US"/>
           </a:p>
@@ -4048,7 +4048,7 @@
           <a:p>
             <a:fld id="{29D38AE0-A022-EC4B-ADED-C3987264F154}" type="datetimeFigureOut">
               <a:rPr kumimoji="1" lang="ja-JP" altLang="en-US" smtClean="0"/>
-              <a:t>2026/9/15</a:t>
+              <a:t>2026/9/28</a:t>
             </a:fld>
             <a:endParaRPr kumimoji="1" lang="ja-JP" altLang="en-US"/>
           </a:p>
@@ -4278,7 +4278,7 @@
           <a:p>
             <a:fld id="{29D38AE0-A022-EC4B-ADED-C3987264F154}" type="datetimeFigureOut">
               <a:rPr kumimoji="1" lang="ja-JP" altLang="en-US" smtClean="0"/>
-              <a:t>2026/9/15</a:t>
+              <a:t>2026/9/28</a:t>
             </a:fld>
             <a:endParaRPr kumimoji="1" lang="ja-JP" altLang="en-US"/>
           </a:p>
@@ -4553,7 +4553,7 @@
           <a:p>
             <a:fld id="{29D38AE0-A022-EC4B-ADED-C3987264F154}" type="datetimeFigureOut">
               <a:rPr kumimoji="1" lang="ja-JP" altLang="en-US" smtClean="0"/>
-              <a:t>2026/9/15</a:t>
+              <a:t>2026/9/28</a:t>
             </a:fld>
             <a:endParaRPr kumimoji="1" lang="ja-JP" altLang="en-US"/>
           </a:p>
@@ -4882,7 +4882,7 @@
           <a:p>
             <a:fld id="{29D38AE0-A022-EC4B-ADED-C3987264F154}" type="datetimeFigureOut">
               <a:rPr kumimoji="1" lang="ja-JP" altLang="en-US" smtClean="0"/>
-              <a:t>2026/9/15</a:t>
+              <a:t>2026/9/28</a:t>
             </a:fld>
             <a:endParaRPr kumimoji="1" lang="ja-JP" altLang="en-US"/>
           </a:p>
@@ -5358,7 +5358,7 @@
           <a:p>
             <a:fld id="{29D38AE0-A022-EC4B-ADED-C3987264F154}" type="datetimeFigureOut">
               <a:rPr kumimoji="1" lang="ja-JP" altLang="en-US" smtClean="0"/>
-              <a:t>2026/9/15</a:t>
+              <a:t>2026/9/28</a:t>
             </a:fld>
             <a:endParaRPr kumimoji="1" lang="ja-JP" altLang="en-US"/>
           </a:p>
@@ -5499,7 +5499,7 @@
           <a:p>
             <a:fld id="{29D38AE0-A022-EC4B-ADED-C3987264F154}" type="datetimeFigureOut">
               <a:rPr kumimoji="1" lang="ja-JP" altLang="en-US" smtClean="0"/>
-              <a:t>2026/9/15</a:t>
+              <a:t>2026/9/28</a:t>
             </a:fld>
             <a:endParaRPr kumimoji="1" lang="ja-JP" altLang="en-US"/>
           </a:p>
@@ -5612,7 +5612,7 @@
           <a:p>
             <a:fld id="{29D38AE0-A022-EC4B-ADED-C3987264F154}" type="datetimeFigureOut">
               <a:rPr kumimoji="1" lang="ja-JP" altLang="en-US" smtClean="0"/>
-              <a:t>2026/9/15</a:t>
+              <a:t>2026/9/28</a:t>
             </a:fld>
             <a:endParaRPr kumimoji="1" lang="ja-JP" altLang="en-US"/>
           </a:p>
@@ -5955,7 +5955,7 @@
           <a:p>
             <a:fld id="{29D38AE0-A022-EC4B-ADED-C3987264F154}" type="datetimeFigureOut">
               <a:rPr kumimoji="1" lang="ja-JP" altLang="en-US" smtClean="0"/>
-              <a:t>2026/9/15</a:t>
+              <a:t>2026/9/28</a:t>
             </a:fld>
             <a:endParaRPr kumimoji="1" lang="ja-JP" altLang="en-US"/>
           </a:p>
@@ -6243,7 +6243,7 @@
           <a:p>
             <a:fld id="{29D38AE0-A022-EC4B-ADED-C3987264F154}" type="datetimeFigureOut">
               <a:rPr kumimoji="1" lang="ja-JP" altLang="en-US" smtClean="0"/>
-              <a:t>2026/9/15</a:t>
+              <a:t>2026/9/28</a:t>
             </a:fld>
             <a:endParaRPr kumimoji="1" lang="ja-JP" altLang="en-US"/>
           </a:p>
@@ -6516,7 +6516,7 @@
           <a:p>
             <a:fld id="{29D38AE0-A022-EC4B-ADED-C3987264F154}" type="datetimeFigureOut">
               <a:rPr kumimoji="1" lang="ja-JP" altLang="en-US" smtClean="0"/>
-              <a:t>2026/9/15</a:t>
+              <a:t>2026/9/28</a:t>
             </a:fld>
             <a:endParaRPr kumimoji="1" lang="ja-JP" altLang="en-US"/>
           </a:p>
@@ -9880,6 +9880,39 @@
                 <a:ea typeface="Hiragino Sans W8" panose="020B0400000000000000" pitchFamily="34" charset="-128"/>
               </a:endParaRPr>
             </a:p>
+            <a:p>
+              <a:pPr algn="ctr"/>
+              <a:r>
+                <a:rPr lang="en-US" altLang="ja-JP" b="1" dirty="0">
+                  <a:solidFill>
+                    <a:schemeClr val="tx1"/>
+                  </a:solidFill>
+                  <a:latin typeface="Hiragino Sans W8" panose="020B0400000000000000" pitchFamily="34" charset="-128"/>
+                  <a:ea typeface="Hiragino Sans W8" panose="020B0400000000000000" pitchFamily="34" charset="-128"/>
+                </a:rPr>
+                <a:t>【1/18</a:t>
+              </a:r>
+              <a:r>
+                <a:rPr lang="ja-JP" altLang="en-US" b="1">
+                  <a:solidFill>
+                    <a:schemeClr val="tx1"/>
+                  </a:solidFill>
+                  <a:latin typeface="Hiragino Sans W8" panose="020B0400000000000000" pitchFamily="34" charset="-128"/>
+                  <a:ea typeface="Hiragino Sans W8" panose="020B0400000000000000" pitchFamily="34" charset="-128"/>
+                </a:rPr>
+                <a:t>補講</a:t>
+              </a:r>
+              <a:r>
+                <a:rPr lang="en-US" altLang="ja-JP" b="1" dirty="0">
+                  <a:solidFill>
+                    <a:schemeClr val="tx1"/>
+                  </a:solidFill>
+                  <a:latin typeface="Hiragino Sans W8" panose="020B0400000000000000" pitchFamily="34" charset="-128"/>
+                  <a:ea typeface="Hiragino Sans W8" panose="020B0400000000000000" pitchFamily="34" charset="-128"/>
+                </a:rPr>
+                <a:t>】</a:t>
+              </a:r>
+            </a:p>
           </p:txBody>
         </p:sp>
         <p:sp>
@@ -10982,6 +11015,76 @@
           </p:txBody>
         </p:sp>
       </p:grpSp>
+      <p:sp>
+        <p:nvSpPr>
+          <p:cNvPr id="3" name="テキスト ボックス 2">
+            <a:extLst>
+              <a:ext uri="{FF2B5EF4-FFF2-40B4-BE49-F238E27FC236}">
+                <a16:creationId xmlns:a16="http://schemas.microsoft.com/office/drawing/2014/main" id="{39CB784F-84F7-408D-CAAC-C06A33307F0E}"/>
+              </a:ext>
+            </a:extLst>
+          </p:cNvPr>
+          <p:cNvSpPr txBox="1"/>
+          <p:nvPr/>
+        </p:nvSpPr>
+        <p:spPr>
+          <a:xfrm>
+            <a:off x="9310593" y="4953238"/>
+            <a:ext cx="1289540" cy="400110"/>
+          </a:xfrm>
+          <a:prstGeom prst="rect">
+            <a:avLst/>
+          </a:prstGeom>
+          <a:solidFill>
+            <a:schemeClr val="bg1"/>
+          </a:solidFill>
+          <a:ln w="38100">
+            <a:solidFill>
+              <a:schemeClr val="tx1"/>
+            </a:solidFill>
+          </a:ln>
+        </p:spPr>
+        <p:txBody>
+          <a:bodyPr wrap="square">
+            <a:spAutoFit/>
+          </a:bodyPr>
+          <a:lstStyle/>
+          <a:p>
+            <a:pPr algn="ctr"/>
+            <a:r>
+              <a:rPr lang="en-US" altLang="ja-JP" sz="2000" b="1" dirty="0">
+                <a:solidFill>
+                  <a:schemeClr val="tx1"/>
+                </a:solidFill>
+                <a:latin typeface="Hiragino Sans W8" panose="020B0400000000000000" pitchFamily="34" charset="-128"/>
+                <a:ea typeface="Hiragino Sans W8" panose="020B0400000000000000" pitchFamily="34" charset="-128"/>
+              </a:rPr>
+              <a:t>【</a:t>
+            </a:r>
+            <a:r>
+              <a:rPr lang="ja-JP" altLang="en-US" sz="2000" b="1">
+                <a:solidFill>
+                  <a:schemeClr val="tx1"/>
+                </a:solidFill>
+                <a:latin typeface="Hiragino Sans W8" panose="020B0400000000000000" pitchFamily="34" charset="-128"/>
+                <a:ea typeface="Hiragino Sans W8" panose="020B0400000000000000" pitchFamily="34" charset="-128"/>
+              </a:rPr>
+              <a:t>休講</a:t>
+            </a:r>
+            <a:r>
+              <a:rPr lang="en-US" altLang="ja-JP" sz="2000" b="1" dirty="0">
+                <a:solidFill>
+                  <a:schemeClr val="tx1"/>
+                </a:solidFill>
+                <a:latin typeface="Hiragino Sans W8" panose="020B0400000000000000" pitchFamily="34" charset="-128"/>
+                <a:ea typeface="Hiragino Sans W8" panose="020B0400000000000000" pitchFamily="34" charset="-128"/>
+              </a:rPr>
+              <a:t>】</a:t>
+            </a:r>
+            <a:endParaRPr lang="ja-JP" altLang="en-US" sz="2000"/>
+          </a:p>
+        </p:txBody>
+      </p:sp>
     </p:spTree>
     <p:extLst>
       <p:ext uri="{BB962C8B-B14F-4D97-AF65-F5344CB8AC3E}">

</xml_diff>